<commit_message>
% current versions, with adaptive 'homeostatic' inhibition
</commit_message>
<xml_diff>
--- a/misc_elm/modelupdatefigures/Model figure.pptx
+++ b/misc_elm/modelupdatefigures/Model figure.pptx
@@ -5,15 +5,16 @@
     <p:sldMasterId id="2147483672" r:id="rId1"/>
   </p:sldMasterIdLst>
   <p:notesMasterIdLst>
-    <p:notesMasterId r:id="rId8"/>
+    <p:notesMasterId r:id="rId9"/>
   </p:notesMasterIdLst>
   <p:sldIdLst>
     <p:sldId id="259" r:id="rId2"/>
     <p:sldId id="256" r:id="rId3"/>
-    <p:sldId id="258" r:id="rId4"/>
-    <p:sldId id="257" r:id="rId5"/>
-    <p:sldId id="260" r:id="rId6"/>
+    <p:sldId id="260" r:id="rId4"/>
+    <p:sldId id="258" r:id="rId5"/>
+    <p:sldId id="257" r:id="rId6"/>
     <p:sldId id="261" r:id="rId7"/>
+    <p:sldId id="262" r:id="rId8"/>
   </p:sldIdLst>
   <p:sldSz cx="6858000" cy="9144000" type="letter"/>
   <p:notesSz cx="6858000" cy="9144000"/>
@@ -218,7 +219,7 @@
           <a:p>
             <a:fld id="{3A89D1C0-E319-4E94-803C-064D848B6B29}" type="datetimeFigureOut">
               <a:rPr lang="en-US" smtClean="0"/>
-              <a:t>11/25/2014</a:t>
+              <a:t>11/27/2014</a:t>
             </a:fld>
             <a:endParaRPr lang="en-US"/>
           </a:p>
@@ -1351,7 +1352,24 @@
           <a:bodyPr/>
           <a:lstStyle/>
           <a:p>
-            <a:endParaRPr lang="en-US" b="0" i="0" u="none" strike="noStrike" baseline="0" dirty="0" smtClean="0"/>
+            <a:pPr marL="0" marR="0" indent="0" algn="l" defTabSz="914400" rtl="0" eaLnBrk="1" fontAlgn="auto" latinLnBrk="0" hangingPunct="1">
+              <a:lnSpc>
+                <a:spcPct val="100000"/>
+              </a:lnSpc>
+              <a:spcBef>
+                <a:spcPts val="0"/>
+              </a:spcBef>
+              <a:spcAft>
+                <a:spcPts val="0"/>
+              </a:spcAft>
+              <a:buClrTx/>
+              <a:buSzTx/>
+              <a:buFontTx/>
+              <a:buNone/>
+              <a:tabLst/>
+              <a:defRPr/>
+            </a:pPr>
+            <a:endParaRPr lang="en-US" dirty="0"/>
           </a:p>
         </p:txBody>
       </p:sp>
@@ -1381,6 +1399,90 @@
     </p:spTree>
     <p:extLst>
       <p:ext uri="{BB962C8B-B14F-4D97-AF65-F5344CB8AC3E}">
+        <p14:creationId xmlns:p14="http://schemas.microsoft.com/office/powerpoint/2010/main" val="3378303168"/>
+      </p:ext>
+    </p:extLst>
+  </p:cSld>
+  <p:clrMapOvr>
+    <a:masterClrMapping/>
+  </p:clrMapOvr>
+</p:notes>
+</file>
+
+<file path=ppt/notesSlides/notesSlide3.xml><?xml version="1.0" encoding="utf-8"?>
+<p:notes xmlns:a="http://schemas.openxmlformats.org/drawingml/2006/main" xmlns:r="http://schemas.openxmlformats.org/officeDocument/2006/relationships" xmlns:p="http://schemas.openxmlformats.org/presentationml/2006/main">
+  <p:cSld>
+    <p:spTree>
+      <p:nvGrpSpPr>
+        <p:cNvPr id="1" name=""/>
+        <p:cNvGrpSpPr/>
+        <p:nvPr/>
+      </p:nvGrpSpPr>
+      <p:grpSpPr>
+        <a:xfrm>
+          <a:off x="0" y="0"/>
+          <a:ext cx="0" cy="0"/>
+          <a:chOff x="0" y="0"/>
+          <a:chExt cx="0" cy="0"/>
+        </a:xfrm>
+      </p:grpSpPr>
+      <p:sp>
+        <p:nvSpPr>
+          <p:cNvPr id="2" name="Slide Image Placeholder 1"/>
+          <p:cNvSpPr>
+            <a:spLocks noGrp="1" noRot="1" noChangeAspect="1"/>
+          </p:cNvSpPr>
+          <p:nvPr>
+            <p:ph type="sldImg"/>
+          </p:nvPr>
+        </p:nvSpPr>
+        <p:spPr/>
+      </p:sp>
+      <p:sp>
+        <p:nvSpPr>
+          <p:cNvPr id="3" name="Notes Placeholder 2"/>
+          <p:cNvSpPr>
+            <a:spLocks noGrp="1"/>
+          </p:cNvSpPr>
+          <p:nvPr>
+            <p:ph type="body" idx="1"/>
+          </p:nvPr>
+        </p:nvSpPr>
+        <p:spPr/>
+        <p:txBody>
+          <a:bodyPr/>
+          <a:lstStyle/>
+          <a:p>
+            <a:endParaRPr lang="en-US" b="0" i="0" u="none" strike="noStrike" baseline="0" dirty="0" smtClean="0"/>
+          </a:p>
+        </p:txBody>
+      </p:sp>
+      <p:sp>
+        <p:nvSpPr>
+          <p:cNvPr id="4" name="Slide Number Placeholder 3"/>
+          <p:cNvSpPr>
+            <a:spLocks noGrp="1"/>
+          </p:cNvSpPr>
+          <p:nvPr>
+            <p:ph type="sldNum" sz="quarter" idx="10"/>
+          </p:nvPr>
+        </p:nvSpPr>
+        <p:spPr/>
+        <p:txBody>
+          <a:bodyPr/>
+          <a:lstStyle/>
+          <a:p>
+            <a:fld id="{AB47A091-1025-4C33-93B2-B19D2608A5C4}" type="slidenum">
+              <a:rPr lang="en-US" smtClean="0"/>
+              <a:t>4</a:t>
+            </a:fld>
+            <a:endParaRPr lang="en-US"/>
+          </a:p>
+        </p:txBody>
+      </p:sp>
+    </p:spTree>
+    <p:extLst>
+      <p:ext uri="{BB962C8B-B14F-4D97-AF65-F5344CB8AC3E}">
         <p14:creationId xmlns:p14="http://schemas.microsoft.com/office/powerpoint/2010/main" val="1379072998"/>
       </p:ext>
     </p:extLst>
@@ -1391,7 +1493,7 @@
 </p:notes>
 </file>
 
-<file path=ppt/notesSlides/notesSlide3.xml><?xml version="1.0" encoding="utf-8"?>
+<file path=ppt/notesSlides/notesSlide4.xml><?xml version="1.0" encoding="utf-8"?>
 <p:notes xmlns:a="http://schemas.openxmlformats.org/drawingml/2006/main" xmlns:r="http://schemas.openxmlformats.org/officeDocument/2006/relationships" xmlns:p="http://schemas.openxmlformats.org/presentationml/2006/main">
   <p:cSld>
     <p:spTree>
@@ -2146,7 +2248,7 @@
           <a:p>
             <a:fld id="{AB47A091-1025-4C33-93B2-B19D2608A5C4}" type="slidenum">
               <a:rPr lang="en-US" smtClean="0"/>
-              <a:t>4</a:t>
+              <a:t>5</a:t>
             </a:fld>
             <a:endParaRPr lang="en-US"/>
           </a:p>
@@ -2165,7 +2267,7 @@
 </p:notes>
 </file>
 
-<file path=ppt/notesSlides/notesSlide4.xml><?xml version="1.0" encoding="utf-8"?>
+<file path=ppt/notesSlides/notesSlide5.xml><?xml version="1.0" encoding="utf-8"?>
 <p:notes xmlns:a="http://schemas.openxmlformats.org/drawingml/2006/main" xmlns:r="http://schemas.openxmlformats.org/officeDocument/2006/relationships" xmlns:p="http://schemas.openxmlformats.org/presentationml/2006/main">
   <p:cSld>
     <p:spTree>
@@ -2209,24 +2311,420 @@
           <a:bodyPr/>
           <a:lstStyle/>
           <a:p>
-            <a:pPr marL="0" marR="0" indent="0" algn="l" defTabSz="914400" rtl="0" eaLnBrk="1" fontAlgn="auto" latinLnBrk="0" hangingPunct="1">
-              <a:lnSpc>
-                <a:spcPct val="100000"/>
-              </a:lnSpc>
-              <a:spcBef>
-                <a:spcPts val="0"/>
-              </a:spcBef>
-              <a:spcAft>
-                <a:spcPts val="0"/>
-              </a:spcAft>
-              <a:buClrTx/>
-              <a:buSzTx/>
-              <a:buFontTx/>
-              <a:buNone/>
-              <a:tabLst/>
-              <a:defRPr/>
-            </a:pPr>
-            <a:endParaRPr lang="en-US" dirty="0"/>
+            <a:r>
+              <a:rPr lang="en-US" sz="1200" b="0" i="0" u="none" strike="noStrike" kern="1200" baseline="0" smtClean="0">
+                <a:solidFill>
+                  <a:schemeClr val="tx1"/>
+                </a:solidFill>
+                <a:latin typeface="+mn-lt"/>
+                <a:ea typeface="+mn-ea"/>
+                <a:cs typeface="+mn-cs"/>
+              </a:rPr>
+              <a:t> </a:t>
+            </a:r>
+          </a:p>
+          <a:p>
+            <a:r>
+              <a:rPr lang="en-US" sz="1200" b="0" i="0" u="none" strike="noStrike" kern="1200" baseline="0" smtClean="0">
+                <a:solidFill>
+                  <a:schemeClr val="tx1"/>
+                </a:solidFill>
+                <a:latin typeface="+mn-lt"/>
+                <a:ea typeface="+mn-ea"/>
+                <a:cs typeface="+mn-cs"/>
+              </a:rPr>
+              <a:t>% INPUTS</a:t>
+            </a:r>
+          </a:p>
+          <a:p>
+            <a:r>
+              <a:rPr lang="en-US" sz="1200" b="0" i="0" u="none" strike="noStrike" kern="1200" baseline="0" smtClean="0">
+                <a:solidFill>
+                  <a:schemeClr val="tx1"/>
+                </a:solidFill>
+                <a:latin typeface="+mn-lt"/>
+                <a:ea typeface="+mn-ea"/>
+                <a:cs typeface="+mn-cs"/>
+              </a:rPr>
+              <a:t>k = 8;          % External input drives k neurons simultaneously</a:t>
+            </a:r>
+          </a:p>
+          <a:p>
+            <a:r>
+              <a:rPr lang="en-US" sz="1200" b="0" i="0" u="none" strike="noStrike" kern="1200" baseline="0" smtClean="0">
+                <a:solidFill>
+                  <a:schemeClr val="tx1"/>
+                </a:solidFill>
+                <a:latin typeface="+mn-lt"/>
+                <a:ea typeface="+mn-ea"/>
+                <a:cs typeface="+mn-cs"/>
+              </a:rPr>
+              <a:t>m = 8;          % Each neuron can have m*wmax incoming(outgoing) synaptic weight before heterosynaptic LTD kicks in</a:t>
+            </a:r>
+          </a:p>
+          <a:p>
+            <a:r>
+              <a:rPr lang="en-US" sz="1200" b="0" i="0" u="none" strike="noStrike" kern="1200" baseline="0" smtClean="0">
+                <a:solidFill>
+                  <a:schemeClr val="tx1"/>
+                </a:solidFill>
+                <a:latin typeface="+mn-lt"/>
+                <a:ea typeface="+mn-ea"/>
+                <a:cs typeface="+mn-cs"/>
+              </a:rPr>
+              <a:t>n = 100;        % Number of neurons</a:t>
+            </a:r>
+          </a:p>
+          <a:p>
+            <a:r>
+              <a:rPr lang="en-US" sz="1200" b="0" i="0" u="none" strike="noStrike" kern="1200" baseline="0" smtClean="0">
+                <a:solidFill>
+                  <a:schemeClr val="tx1"/>
+                </a:solidFill>
+                <a:latin typeface="+mn-lt"/>
+                <a:ea typeface="+mn-ea"/>
+                <a:cs typeface="+mn-cs"/>
+              </a:rPr>
+              <a:t>trainint = 10;  % Interval between training input</a:t>
+            </a:r>
+          </a:p>
+          <a:p>
+            <a:r>
+              <a:rPr lang="en-US" sz="1200" b="0" i="0" u="none" strike="noStrike" kern="1200" baseline="0" smtClean="0">
+                <a:solidFill>
+                  <a:schemeClr val="tx1"/>
+                </a:solidFill>
+                <a:latin typeface="+mn-lt"/>
+                <a:ea typeface="+mn-ea"/>
+                <a:cs typeface="+mn-cs"/>
+              </a:rPr>
+              <a:t>beta = .3;      % Strength of feed-forward inhibition. .02 for trainint 10</a:t>
+            </a:r>
+          </a:p>
+          <a:p>
+            <a:r>
+              <a:rPr lang="en-US" sz="1200" b="0" i="0" u="none" strike="noStrike" kern="1200" baseline="0" smtClean="0">
+                <a:solidFill>
+                  <a:schemeClr val="tx1"/>
+                </a:solidFill>
+                <a:latin typeface="+mn-lt"/>
+                <a:ea typeface="+mn-ea"/>
+                <a:cs typeface="+mn-cs"/>
+              </a:rPr>
+              <a:t>eta = .02;      % Overall learning rate</a:t>
+            </a:r>
+          </a:p>
+          <a:p>
+            <a:r>
+              <a:rPr lang="en-US" sz="1200" b="0" i="0" u="none" strike="noStrike" kern="1200" baseline="0" smtClean="0">
+                <a:solidFill>
+                  <a:schemeClr val="tx1"/>
+                </a:solidFill>
+                <a:latin typeface="+mn-lt"/>
+                <a:ea typeface="+mn-ea"/>
+                <a:cs typeface="+mn-cs"/>
+              </a:rPr>
+              <a:t>epsilon = .01;  % Relative strength of heterosynaptic LTD</a:t>
+            </a:r>
+          </a:p>
+          <a:p>
+            <a:r>
+              <a:rPr lang="en-US" sz="1200" b="0" i="0" u="none" strike="noStrike" kern="1200" baseline="0" smtClean="0">
+                <a:solidFill>
+                  <a:schemeClr val="tx1"/>
+                </a:solidFill>
+                <a:latin typeface="+mn-lt"/>
+                <a:ea typeface="+mn-ea"/>
+                <a:cs typeface="+mn-cs"/>
+              </a:rPr>
+              <a:t>pin = .01;      % Probability of random activation of any one neuron</a:t>
+            </a:r>
+          </a:p>
+          <a:p>
+            <a:r>
+              <a:rPr lang="en-US" sz="1200" b="0" i="0" u="none" strike="noStrike" kern="1200" baseline="0" smtClean="0">
+                <a:solidFill>
+                  <a:schemeClr val="tx1"/>
+                </a:solidFill>
+                <a:latin typeface="+mn-lt"/>
+                <a:ea typeface="+mn-ea"/>
+                <a:cs typeface="+mn-cs"/>
+              </a:rPr>
+              <a:t>vidname = [];   % Save video name (leave empty [] if unneeded)</a:t>
+            </a:r>
+          </a:p>
+          <a:p>
+            <a:r>
+              <a:rPr lang="en-US" sz="1200" b="0" i="0" u="none" strike="noStrike" kern="1200" baseline="0" smtClean="0">
+                <a:solidFill>
+                  <a:schemeClr val="tx1"/>
+                </a:solidFill>
+                <a:latin typeface="+mn-lt"/>
+                <a:ea typeface="+mn-ea"/>
+                <a:cs typeface="+mn-cs"/>
+              </a:rPr>
+              <a:t>vidname2 = [];</a:t>
+            </a:r>
+          </a:p>
+          <a:p>
+            <a:r>
+              <a:rPr lang="en-US" sz="1200" b="0" i="0" u="none" strike="noStrike" kern="1200" baseline="0" smtClean="0">
+                <a:solidFill>
+                  <a:schemeClr val="tx1"/>
+                </a:solidFill>
+                <a:latin typeface="+mn-lt"/>
+                <a:ea typeface="+mn-ea"/>
+                <a:cs typeface="+mn-cs"/>
+              </a:rPr>
+              <a:t>psuccess = 1;   % P firing given above thresh activity - leave at 1</a:t>
+            </a:r>
+          </a:p>
+          <a:p>
+            <a:r>
+              <a:rPr lang="en-US" sz="1200" b="0" i="0" u="none" strike="noStrike" kern="1200" baseline="0" smtClean="0">
+                <a:solidFill>
+                  <a:schemeClr val="tx1"/>
+                </a:solidFill>
+                <a:latin typeface="+mn-lt"/>
+                <a:ea typeface="+mn-ea"/>
+                <a:cs typeface="+mn-cs"/>
+              </a:rPr>
+              <a:t>gamma = 0;     % Level of lateral inhibition at baseline</a:t>
+            </a:r>
+          </a:p>
+          <a:p>
+            <a:r>
+              <a:rPr lang="en-US" sz="1200" b="0" i="0" u="none" strike="noStrike" kern="1200" baseline="0" smtClean="0">
+                <a:solidFill>
+                  <a:schemeClr val="tx1"/>
+                </a:solidFill>
+                <a:latin typeface="+mn-lt"/>
+                <a:ea typeface="+mn-ea"/>
+                <a:cs typeface="+mn-cs"/>
+              </a:rPr>
+              <a:t>alpha = 0;      % Strength of adaptation (50 good)</a:t>
+            </a:r>
+          </a:p>
+          <a:p>
+            <a:r>
+              <a:rPr lang="en-US" sz="1200" b="0" i="0" u="none" strike="noStrike" kern="1200" baseline="0" smtClean="0">
+                <a:solidFill>
+                  <a:schemeClr val="tx1"/>
+                </a:solidFill>
+                <a:latin typeface="+mn-lt"/>
+                <a:ea typeface="+mn-ea"/>
+                <a:cs typeface="+mn-cs"/>
+              </a:rPr>
+              <a:t>% OUTPUTS</a:t>
+            </a:r>
+          </a:p>
+          <a:p>
+            <a:r>
+              <a:rPr lang="en-US" sz="1200" b="0" i="0" u="none" strike="noStrike" kern="1200" baseline="0" smtClean="0">
+                <a:solidFill>
+                  <a:schemeClr val="tx1"/>
+                </a:solidFill>
+                <a:latin typeface="+mn-lt"/>
+                <a:ea typeface="+mn-ea"/>
+                <a:cs typeface="+mn-cs"/>
+              </a:rPr>
+              <a:t>% w: weight matrix</a:t>
+            </a:r>
+          </a:p>
+          <a:p>
+            <a:r>
+              <a:rPr lang="en-US" sz="1200" b="0" i="0" u="none" strike="noStrike" kern="1200" baseline="0" smtClean="0">
+                <a:solidFill>
+                  <a:schemeClr val="tx1"/>
+                </a:solidFill>
+                <a:latin typeface="+mn-lt"/>
+                <a:ea typeface="+mn-ea"/>
+                <a:cs typeface="+mn-cs"/>
+              </a:rPr>
+              <a:t>% p: structure of parameters</a:t>
+            </a:r>
+          </a:p>
+          <a:p>
+            <a:r>
+              <a:rPr lang="en-US" sz="1200" b="0" i="0" u="none" strike="noStrike" kern="1200" baseline="0" smtClean="0">
+                <a:solidFill>
+                  <a:schemeClr val="tx1"/>
+                </a:solidFill>
+                <a:latin typeface="+mn-lt"/>
+                <a:ea typeface="+mn-ea"/>
+                <a:cs typeface="+mn-cs"/>
+              </a:rPr>
+              <a:t> </a:t>
+            </a:r>
+          </a:p>
+          <a:p>
+            <a:r>
+              <a:rPr lang="en-US" sz="1200" b="0" i="0" u="none" strike="noStrike" kern="1200" baseline="0" smtClean="0">
+                <a:solidFill>
+                  <a:schemeClr val="tx1"/>
+                </a:solidFill>
+                <a:latin typeface="+mn-lt"/>
+                <a:ea typeface="+mn-ea"/>
+                <a:cs typeface="+mn-cs"/>
+              </a:rPr>
+              <a:t>[w0, ~, ~, p] = simSplit('w',[],'wmax',1,'split',0,'recordvid',vidname,...</a:t>
+            </a:r>
+          </a:p>
+          <a:p>
+            <a:r>
+              <a:rPr lang="en-US" sz="1200" b="0" i="0" u="none" strike="noStrike" kern="1200" baseline="0" smtClean="0">
+                <a:solidFill>
+                  <a:schemeClr val="tx1"/>
+                </a:solidFill>
+                <a:latin typeface="+mn-lt"/>
+                <a:ea typeface="+mn-ea"/>
+                <a:cs typeface="+mn-cs"/>
+              </a:rPr>
+              <a:t>    'n',n,'m',m,'k',k,'beta',beta,'trainint',trainint,...</a:t>
+            </a:r>
+          </a:p>
+          <a:p>
+            <a:r>
+              <a:rPr lang="en-US" sz="1200" b="0" i="0" u="none" strike="noStrike" kern="1200" baseline="0" smtClean="0">
+                <a:solidFill>
+                  <a:schemeClr val="tx1"/>
+                </a:solidFill>
+                <a:latin typeface="+mn-lt"/>
+                <a:ea typeface="+mn-ea"/>
+                <a:cs typeface="+mn-cs"/>
+              </a:rPr>
+              <a:t>    'eta',eta,'pin',pin,'gamma',gamma,'epsilon',epsilon,...</a:t>
+            </a:r>
+          </a:p>
+          <a:p>
+            <a:r>
+              <a:rPr lang="en-US" sz="1200" b="0" i="0" u="none" strike="noStrike" kern="1200" baseline="0" smtClean="0">
+                <a:solidFill>
+                  <a:schemeClr val="tx1"/>
+                </a:solidFill>
+                <a:latin typeface="+mn-lt"/>
+                <a:ea typeface="+mn-ea"/>
+                <a:cs typeface="+mn-cs"/>
+              </a:rPr>
+              <a:t>    'niters',1000,'psuccess',psuccess,'alpha',alpha);</a:t>
+            </a:r>
+          </a:p>
+          <a:p>
+            <a:r>
+              <a:rPr lang="en-US" sz="1200" b="0" i="0" u="none" strike="noStrike" kern="1200" baseline="0" smtClean="0">
+                <a:solidFill>
+                  <a:schemeClr val="tx1"/>
+                </a:solidFill>
+                <a:latin typeface="+mn-lt"/>
+                <a:ea typeface="+mn-ea"/>
+                <a:cs typeface="+mn-cs"/>
+              </a:rPr>
+              <a:t> </a:t>
+            </a:r>
+          </a:p>
+          <a:p>
+            <a:r>
+              <a:rPr lang="en-US" sz="1200" b="0" i="0" u="none" strike="noStrike" kern="1200" baseline="0" smtClean="0">
+                <a:solidFill>
+                  <a:schemeClr val="tx1"/>
+                </a:solidFill>
+                <a:latin typeface="+mn-lt"/>
+                <a:ea typeface="+mn-ea"/>
+                <a:cs typeface="+mn-cs"/>
+              </a:rPr>
+              <a:t>%% SPLIT</a:t>
+            </a:r>
+          </a:p>
+          <a:p>
+            <a:r>
+              <a:rPr lang="en-US" sz="1200" b="0" i="0" u="none" strike="noStrike" kern="1200" baseline="0" smtClean="0">
+                <a:solidFill>
+                  <a:schemeClr val="tx1"/>
+                </a:solidFill>
+                <a:latin typeface="+mn-lt"/>
+                <a:ea typeface="+mn-ea"/>
+                <a:cs typeface="+mn-cs"/>
+              </a:rPr>
+              <a:t>% 1. Allow fewer, stronger synapses (wmax = 2, m = m/2)</a:t>
+            </a:r>
+          </a:p>
+          <a:p>
+            <a:r>
+              <a:rPr lang="en-US" sz="1200" b="0" i="0" u="none" strike="noStrike" kern="1200" baseline="0" smtClean="0">
+                <a:solidFill>
+                  <a:schemeClr val="tx1"/>
+                </a:solidFill>
+                <a:latin typeface="+mn-lt"/>
+                <a:ea typeface="+mn-ea"/>
+                <a:cs typeface="+mn-cs"/>
+              </a:rPr>
+              <a:t>% 2. Split up training inputs into two groups (split = 1)</a:t>
+            </a:r>
+          </a:p>
+          <a:p>
+            <a:r>
+              <a:rPr lang="en-US" sz="1200" b="0" i="0" u="none" strike="noStrike" kern="1200" baseline="0" smtClean="0">
+                <a:solidFill>
+                  <a:schemeClr val="tx1"/>
+                </a:solidFill>
+                <a:latin typeface="+mn-lt"/>
+                <a:ea typeface="+mn-ea"/>
+                <a:cs typeface="+mn-cs"/>
+              </a:rPr>
+              <a:t>% 3. Increase lateral inhibition (gamma = .7-.9)</a:t>
+            </a:r>
+          </a:p>
+          <a:p>
+            <a:r>
+              <a:rPr lang="en-US" sz="1200" b="0" i="0" u="none" strike="noStrike" kern="1200" baseline="0" smtClean="0">
+                <a:solidFill>
+                  <a:schemeClr val="tx1"/>
+                </a:solidFill>
+                <a:latin typeface="+mn-lt"/>
+                <a:ea typeface="+mn-ea"/>
+                <a:cs typeface="+mn-cs"/>
+              </a:rPr>
+              <a:t>[w1, ~, ~, psplit]= simSplit('w',w0,'wmax',2,'split',1,'recordvid',vidname2,...</a:t>
+            </a:r>
+          </a:p>
+          <a:p>
+            <a:r>
+              <a:rPr lang="en-US" sz="1200" b="0" i="0" u="none" strike="noStrike" kern="1200" baseline="0" smtClean="0">
+                <a:solidFill>
+                  <a:schemeClr val="tx1"/>
+                </a:solidFill>
+                <a:latin typeface="+mn-lt"/>
+                <a:ea typeface="+mn-ea"/>
+                <a:cs typeface="+mn-cs"/>
+              </a:rPr>
+              <a:t>    'n',n,'m',m/2,'k',k,'beta',beta,'trainint',trainint,...</a:t>
+            </a:r>
+          </a:p>
+          <a:p>
+            <a:r>
+              <a:rPr lang="sv-SE" sz="1200" b="0" i="0" u="none" strike="noStrike" kern="1200" baseline="0" smtClean="0">
+                <a:solidFill>
+                  <a:schemeClr val="tx1"/>
+                </a:solidFill>
+                <a:latin typeface="+mn-lt"/>
+                <a:ea typeface="+mn-ea"/>
+                <a:cs typeface="+mn-cs"/>
+              </a:rPr>
+              <a:t>    'eta',eta*2,'pin',pin,'gamma',.9,'epsilon',epsilon,...</a:t>
+            </a:r>
+          </a:p>
+          <a:p>
+            <a:r>
+              <a:rPr lang="en-US" sz="1200" b="0" i="0" u="none" strike="noStrike" kern="1200" baseline="0" smtClean="0">
+                <a:solidFill>
+                  <a:schemeClr val="tx1"/>
+                </a:solidFill>
+                <a:latin typeface="+mn-lt"/>
+                <a:ea typeface="+mn-ea"/>
+                <a:cs typeface="+mn-cs"/>
+              </a:rPr>
+              <a:t>    'niters',1000,'psuccess',psuccess); </a:t>
+            </a:r>
           </a:p>
         </p:txBody>
       </p:sp>
@@ -2247,7 +2745,7 @@
           <a:p>
             <a:fld id="{AB47A091-1025-4C33-93B2-B19D2608A5C4}" type="slidenum">
               <a:rPr lang="en-US" smtClean="0"/>
-              <a:t>5</a:t>
+              <a:t>7</a:t>
             </a:fld>
             <a:endParaRPr lang="en-US"/>
           </a:p>
@@ -2256,7 +2754,7 @@
     </p:spTree>
     <p:extLst>
       <p:ext uri="{BB962C8B-B14F-4D97-AF65-F5344CB8AC3E}">
-        <p14:creationId xmlns:p14="http://schemas.microsoft.com/office/powerpoint/2010/main" val="3378303168"/>
+        <p14:creationId xmlns:p14="http://schemas.microsoft.com/office/powerpoint/2010/main" val="65585884"/>
       </p:ext>
     </p:extLst>
   </p:cSld>
@@ -2397,7 +2895,7 @@
           <a:p>
             <a:fld id="{6D3B8F5F-B93C-4F22-A857-204BD70249D1}" type="datetimeFigureOut">
               <a:rPr lang="en-US" smtClean="0"/>
-              <a:t>11/25/2014</a:t>
+              <a:t>11/27/2014</a:t>
             </a:fld>
             <a:endParaRPr lang="en-US"/>
           </a:p>
@@ -2567,7 +3065,7 @@
           <a:p>
             <a:fld id="{6D3B8F5F-B93C-4F22-A857-204BD70249D1}" type="datetimeFigureOut">
               <a:rPr lang="en-US" smtClean="0"/>
-              <a:t>11/25/2014</a:t>
+              <a:t>11/27/2014</a:t>
             </a:fld>
             <a:endParaRPr lang="en-US"/>
           </a:p>
@@ -2747,7 +3245,7 @@
           <a:p>
             <a:fld id="{6D3B8F5F-B93C-4F22-A857-204BD70249D1}" type="datetimeFigureOut">
               <a:rPr lang="en-US" smtClean="0"/>
-              <a:t>11/25/2014</a:t>
+              <a:t>11/27/2014</a:t>
             </a:fld>
             <a:endParaRPr lang="en-US"/>
           </a:p>
@@ -2917,7 +3415,7 @@
           <a:p>
             <a:fld id="{6D3B8F5F-B93C-4F22-A857-204BD70249D1}" type="datetimeFigureOut">
               <a:rPr lang="en-US" smtClean="0"/>
-              <a:t>11/25/2014</a:t>
+              <a:t>11/27/2014</a:t>
             </a:fld>
             <a:endParaRPr lang="en-US"/>
           </a:p>
@@ -3161,7 +3659,7 @@
           <a:p>
             <a:fld id="{6D3B8F5F-B93C-4F22-A857-204BD70249D1}" type="datetimeFigureOut">
               <a:rPr lang="en-US" smtClean="0"/>
-              <a:t>11/25/2014</a:t>
+              <a:t>11/27/2014</a:t>
             </a:fld>
             <a:endParaRPr lang="en-US"/>
           </a:p>
@@ -3393,7 +3891,7 @@
           <a:p>
             <a:fld id="{6D3B8F5F-B93C-4F22-A857-204BD70249D1}" type="datetimeFigureOut">
               <a:rPr lang="en-US" smtClean="0"/>
-              <a:t>11/25/2014</a:t>
+              <a:t>11/27/2014</a:t>
             </a:fld>
             <a:endParaRPr lang="en-US"/>
           </a:p>
@@ -3760,7 +4258,7 @@
           <a:p>
             <a:fld id="{6D3B8F5F-B93C-4F22-A857-204BD70249D1}" type="datetimeFigureOut">
               <a:rPr lang="en-US" smtClean="0"/>
-              <a:t>11/25/2014</a:t>
+              <a:t>11/27/2014</a:t>
             </a:fld>
             <a:endParaRPr lang="en-US"/>
           </a:p>
@@ -3878,7 +4376,7 @@
           <a:p>
             <a:fld id="{6D3B8F5F-B93C-4F22-A857-204BD70249D1}" type="datetimeFigureOut">
               <a:rPr lang="en-US" smtClean="0"/>
-              <a:t>11/25/2014</a:t>
+              <a:t>11/27/2014</a:t>
             </a:fld>
             <a:endParaRPr lang="en-US"/>
           </a:p>
@@ -3973,7 +4471,7 @@
           <a:p>
             <a:fld id="{6D3B8F5F-B93C-4F22-A857-204BD70249D1}" type="datetimeFigureOut">
               <a:rPr lang="en-US" smtClean="0"/>
-              <a:t>11/25/2014</a:t>
+              <a:t>11/27/2014</a:t>
             </a:fld>
             <a:endParaRPr lang="en-US"/>
           </a:p>
@@ -4250,7 +4748,7 @@
           <a:p>
             <a:fld id="{6D3B8F5F-B93C-4F22-A857-204BD70249D1}" type="datetimeFigureOut">
               <a:rPr lang="en-US" smtClean="0"/>
-              <a:t>11/25/2014</a:t>
+              <a:t>11/27/2014</a:t>
             </a:fld>
             <a:endParaRPr lang="en-US"/>
           </a:p>
@@ -4507,7 +5005,7 @@
           <a:p>
             <a:fld id="{6D3B8F5F-B93C-4F22-A857-204BD70249D1}" type="datetimeFigureOut">
               <a:rPr lang="en-US" smtClean="0"/>
-              <a:t>11/25/2014</a:t>
+              <a:t>11/27/2014</a:t>
             </a:fld>
             <a:endParaRPr lang="en-US"/>
           </a:p>
@@ -4720,7 +5218,7 @@
           <a:p>
             <a:fld id="{6D3B8F5F-B93C-4F22-A857-204BD70249D1}" type="datetimeFigureOut">
               <a:rPr lang="en-US" smtClean="0"/>
-              <a:t>11/25/2014</a:t>
+              <a:t>11/27/2014</a:t>
             </a:fld>
             <a:endParaRPr lang="en-US"/>
           </a:p>
@@ -5173,7 +5671,7 @@
         </p:spPr>
         <p:txBody>
           <a:bodyPr>
-            <a:normAutofit/>
+            <a:normAutofit lnSpcReduction="10000"/>
           </a:bodyPr>
           <a:lstStyle/>
           <a:p>
@@ -5183,8 +5681,67 @@
             </a:pPr>
             <a:r>
               <a:rPr lang="en-US" sz="1600" dirty="0" smtClean="0"/>
-              <a:t>Main schematic of protosyllable and differentiation</a:t>
+              <a:t>Main schematic of protosyllable </a:t>
             </a:r>
+            <a:r>
+              <a:rPr lang="en-US" sz="1600" smtClean="0"/>
+              <a:t>and differentiation</a:t>
+            </a:r>
+          </a:p>
+          <a:p>
+            <a:pPr marL="457200" indent="-457200">
+              <a:buFont typeface="+mj-lt"/>
+              <a:buAutoNum type="arabicPeriod"/>
+            </a:pPr>
+            <a:r>
+              <a:rPr lang="en-US" sz="1600"/>
+              <a:t>Quantifications</a:t>
+            </a:r>
+          </a:p>
+          <a:p>
+            <a:pPr marL="800100" lvl="1" indent="-457200">
+              <a:buFont typeface="+mj-lt"/>
+              <a:buAutoNum type="arabicPeriod"/>
+            </a:pPr>
+            <a:r>
+              <a:rPr lang="en-US" sz="1600"/>
+              <a:t>Distribution of timings within syllable</a:t>
+            </a:r>
+          </a:p>
+          <a:p>
+            <a:pPr marL="800100" lvl="1" indent="-457200">
+              <a:buFont typeface="+mj-lt"/>
+              <a:buAutoNum type="arabicPeriod"/>
+            </a:pPr>
+            <a:r>
+              <a:rPr lang="en-US" sz="1600"/>
+              <a:t>Position within chain in daughter syllables</a:t>
+            </a:r>
+          </a:p>
+          <a:p>
+            <a:pPr marL="800100" lvl="1" indent="-457200">
+              <a:buFont typeface="+mj-lt"/>
+              <a:buAutoNum type="arabicPeriod"/>
+            </a:pPr>
+            <a:r>
+              <a:rPr lang="en-US" sz="1600"/>
+              <a:t>% differentiated over time</a:t>
+            </a:r>
+          </a:p>
+          <a:p>
+            <a:pPr marL="800100" lvl="1" indent="-457200">
+              <a:buFont typeface="+mj-lt"/>
+              <a:buAutoNum type="arabicPeriod"/>
+            </a:pPr>
+            <a:r>
+              <a:rPr lang="en-US" sz="1600"/>
+              <a:t>Average period of neural activity over </a:t>
+            </a:r>
+            <a:r>
+              <a:rPr lang="en-US" sz="1600" smtClean="0"/>
+              <a:t>time</a:t>
+            </a:r>
+            <a:endParaRPr lang="en-US" sz="1600" dirty="0" smtClean="0"/>
           </a:p>
           <a:p>
             <a:pPr marL="457200" indent="-457200">
@@ -5212,81 +5769,13 @@
               <a:buAutoNum type="arabicPeriod"/>
             </a:pPr>
             <a:r>
-              <a:rPr lang="en-US" sz="1600" dirty="0" smtClean="0"/>
-              <a:t>Quantifications</a:t>
-            </a:r>
-          </a:p>
-          <a:p>
-            <a:pPr marL="800100" lvl="1" indent="-457200">
-              <a:buFont typeface="+mj-lt"/>
-              <a:buAutoNum type="arabicPeriod"/>
-            </a:pPr>
-            <a:r>
-              <a:rPr lang="en-US" sz="1600" dirty="0" smtClean="0"/>
-              <a:t>Distribution </a:t>
-            </a:r>
-            <a:r>
-              <a:rPr lang="en-US" sz="1600" dirty="0"/>
-              <a:t>of timings within syllable</a:t>
-            </a:r>
-          </a:p>
-          <a:p>
-            <a:pPr marL="800100" lvl="1" indent="-457200">
-              <a:buFont typeface="+mj-lt"/>
-              <a:buAutoNum type="arabicPeriod"/>
-            </a:pPr>
-            <a:r>
-              <a:rPr lang="en-US" sz="1600" dirty="0"/>
-              <a:t>Position within chain in daughter </a:t>
+              <a:rPr lang="en-US" sz="1600" smtClean="0"/>
+              <a:t>Generalized </a:t>
             </a:r>
             <a:r>
               <a:rPr lang="en-US" sz="1600" dirty="0" smtClean="0"/>
-              <a:t>syllables</a:t>
+              <a:t>for probabilistic firing (P(spike) ranges from 0 to 1 based on input strength)</a:t>
             </a:r>
-          </a:p>
-          <a:p>
-            <a:pPr marL="800100" lvl="1" indent="-457200">
-              <a:buFont typeface="+mj-lt"/>
-              <a:buAutoNum type="arabicPeriod"/>
-            </a:pPr>
-            <a:r>
-              <a:rPr lang="en-US" sz="1600" dirty="0" smtClean="0"/>
-              <a:t>% </a:t>
-            </a:r>
-            <a:r>
-              <a:rPr lang="en-US" sz="1600" dirty="0"/>
-              <a:t>differentiated </a:t>
-            </a:r>
-            <a:r>
-              <a:rPr lang="en-US" sz="1600" dirty="0" smtClean="0"/>
-              <a:t>over time</a:t>
-            </a:r>
-            <a:endParaRPr lang="en-US" sz="1600" dirty="0"/>
-          </a:p>
-          <a:p>
-            <a:pPr marL="800100" lvl="1" indent="-457200">
-              <a:buFont typeface="+mj-lt"/>
-              <a:buAutoNum type="arabicPeriod"/>
-            </a:pPr>
-            <a:r>
-              <a:rPr lang="en-US" sz="1600" dirty="0" smtClean="0"/>
-              <a:t>Average period of neural activity over </a:t>
-            </a:r>
-            <a:r>
-              <a:rPr lang="en-US" sz="1600" dirty="0" smtClean="0"/>
-              <a:t>time</a:t>
-            </a:r>
-          </a:p>
-          <a:p>
-            <a:pPr marL="457200" indent="-457200">
-              <a:buFont typeface="+mj-lt"/>
-              <a:buAutoNum type="arabicPeriod"/>
-            </a:pPr>
-            <a:r>
-              <a:rPr lang="en-US" sz="1600" dirty="0" smtClean="0"/>
-              <a:t>Generalized for probabilistic firing (P(spike) ranges from 0 to 1 based on input strength)</a:t>
-            </a:r>
-            <a:endParaRPr lang="en-US" sz="1600" dirty="0" smtClean="0"/>
           </a:p>
           <a:p>
             <a:pPr marL="342900" lvl="1" indent="0">
@@ -5341,8 +5830,33 @@
             </a:pPr>
             <a:r>
               <a:rPr lang="en-US" sz="1600" dirty="0" smtClean="0"/>
-              <a:t>Simultaneous splitting of protosyllable into three groups</a:t>
+              <a:t>Simultaneous splitting of protosyllable into </a:t>
             </a:r>
+            <a:r>
+              <a:rPr lang="en-US" sz="1600" smtClean="0"/>
+              <a:t>three groups</a:t>
+            </a:r>
+          </a:p>
+          <a:p>
+            <a:pPr marL="457200" indent="-457200">
+              <a:buFont typeface="+mj-lt"/>
+              <a:buAutoNum type="arabicPeriod"/>
+            </a:pPr>
+            <a:r>
+              <a:rPr lang="en-US" sz="1600" smtClean="0"/>
+              <a:t>Make sure it works with wider STDP window?</a:t>
+            </a:r>
+          </a:p>
+          <a:p>
+            <a:pPr marL="457200" indent="-457200">
+              <a:buFont typeface="+mj-lt"/>
+              <a:buAutoNum type="arabicPeriod"/>
+            </a:pPr>
+            <a:r>
+              <a:rPr lang="en-US" sz="1600" smtClean="0"/>
+              <a:t>Ila includes (Wij/wmax + .001) term for STDP, makes solution more stable – include?</a:t>
+            </a:r>
+            <a:endParaRPr lang="en-US" sz="1600" dirty="0" smtClean="0"/>
           </a:p>
           <a:p>
             <a:pPr marL="457200" indent="-457200">
@@ -6011,11 +6525,25 @@
               <a:defRPr/>
             </a:pPr>
             <a:r>
+              <a:rPr lang="en-US" sz="1100">
+                <a:latin typeface="Arial" panose="020B0604020202020204" pitchFamily="34" charset="0"/>
+                <a:cs typeface="Arial" panose="020B0604020202020204" pitchFamily="34" charset="0"/>
+              </a:rPr>
+              <a:t>Figure </a:t>
+            </a:r>
+            <a:r>
+              <a:rPr lang="en-US" sz="1100" smtClean="0">
+                <a:latin typeface="Arial" panose="020B0604020202020204" pitchFamily="34" charset="0"/>
+                <a:cs typeface="Arial" panose="020B0604020202020204" pitchFamily="34" charset="0"/>
+              </a:rPr>
+              <a:t>1: </a:t>
+            </a:r>
+            <a:r>
               <a:rPr lang="en-US" sz="1100" dirty="0">
                 <a:latin typeface="Arial" panose="020B0604020202020204" pitchFamily="34" charset="0"/>
                 <a:cs typeface="Arial" panose="020B0604020202020204" pitchFamily="34" charset="0"/>
               </a:rPr>
-              <a:t>Figure 6: Computational model of the splitting of a neural </a:t>
+              <a:t>Computational model of the splitting of a neural </a:t>
             </a:r>
             <a:r>
               <a:rPr lang="en-US" sz="1100" dirty="0" smtClean="0">
@@ -6126,640 +6654,6 @@
 </file>
 
 <file path=ppt/slides/slide3.xml><?xml version="1.0" encoding="utf-8"?>
-<p:sld xmlns:a="http://schemas.openxmlformats.org/drawingml/2006/main" xmlns:r="http://schemas.openxmlformats.org/officeDocument/2006/relationships" xmlns:p="http://schemas.openxmlformats.org/presentationml/2006/main">
-  <p:cSld>
-    <p:spTree>
-      <p:nvGrpSpPr>
-        <p:cNvPr id="1" name=""/>
-        <p:cNvGrpSpPr/>
-        <p:nvPr/>
-      </p:nvGrpSpPr>
-      <p:grpSpPr>
-        <a:xfrm>
-          <a:off x="0" y="0"/>
-          <a:ext cx="0" cy="0"/>
-          <a:chOff x="0" y="0"/>
-          <a:chExt cx="0" cy="0"/>
-        </a:xfrm>
-      </p:grpSpPr>
-      <p:sp>
-        <p:nvSpPr>
-          <p:cNvPr id="2" name="Title 1"/>
-          <p:cNvSpPr>
-            <a:spLocks noGrp="1"/>
-          </p:cNvSpPr>
-          <p:nvPr>
-            <p:ph type="title"/>
-          </p:nvPr>
-        </p:nvSpPr>
-        <p:spPr>
-          <a:xfrm>
-            <a:off x="85408" y="11227"/>
-            <a:ext cx="5915025" cy="723703"/>
-          </a:xfrm>
-        </p:spPr>
-        <p:txBody>
-          <a:bodyPr>
-            <a:normAutofit/>
-          </a:bodyPr>
-          <a:lstStyle/>
-          <a:p>
-            <a:r>
-              <a:rPr lang="en-US" sz="1400" dirty="0" smtClean="0">
-                <a:latin typeface="Arial" panose="020B0604020202020204" pitchFamily="34" charset="0"/>
-                <a:cs typeface="Arial" panose="020B0604020202020204" pitchFamily="34" charset="0"/>
-              </a:rPr>
-              <a:t>Generalized to wider chains:</a:t>
-            </a:r>
-            <a:br>
-              <a:rPr lang="en-US" sz="1400" dirty="0" smtClean="0">
-                <a:latin typeface="Arial" panose="020B0604020202020204" pitchFamily="34" charset="0"/>
-                <a:cs typeface="Arial" panose="020B0604020202020204" pitchFamily="34" charset="0"/>
-              </a:rPr>
-            </a:br>
-            <a:r>
-              <a:rPr lang="en-US" sz="1400" dirty="0" smtClean="0">
-                <a:latin typeface="Arial" panose="020B0604020202020204" pitchFamily="34" charset="0"/>
-                <a:cs typeface="Arial" panose="020B0604020202020204" pitchFamily="34" charset="0"/>
-              </a:rPr>
-              <a:t>Number of training neurons determines chain width</a:t>
-            </a:r>
-            <a:endParaRPr lang="en-US" sz="1400" dirty="0">
-              <a:latin typeface="Arial" panose="020B0604020202020204" pitchFamily="34" charset="0"/>
-              <a:cs typeface="Arial" panose="020B0604020202020204" pitchFamily="34" charset="0"/>
-            </a:endParaRPr>
-          </a:p>
-        </p:txBody>
-      </p:sp>
-      <p:sp>
-        <p:nvSpPr>
-          <p:cNvPr id="5" name="Rectangle 4"/>
-          <p:cNvSpPr/>
-          <p:nvPr/>
-        </p:nvSpPr>
-        <p:spPr>
-          <a:xfrm>
-            <a:off x="218413" y="634676"/>
-            <a:ext cx="1648488" cy="307777"/>
-          </a:xfrm>
-          <a:prstGeom prst="rect">
-            <a:avLst/>
-          </a:prstGeom>
-          <a:ln>
-            <a:solidFill>
-              <a:schemeClr val="tx1"/>
-            </a:solidFill>
-          </a:ln>
-        </p:spPr>
-        <p:txBody>
-          <a:bodyPr wrap="square">
-            <a:spAutoFit/>
-          </a:bodyPr>
-          <a:lstStyle/>
-          <a:p>
-            <a:r>
-              <a:rPr lang="en-US" sz="1400" dirty="0" smtClean="0">
-                <a:latin typeface="Arial" panose="020B0604020202020204" pitchFamily="34" charset="0"/>
-                <a:cs typeface="Arial" panose="020B0604020202020204" pitchFamily="34" charset="0"/>
-              </a:rPr>
-              <a:t>16 training inputs</a:t>
-            </a:r>
-            <a:endParaRPr lang="en-US" sz="1400" dirty="0">
-              <a:latin typeface="Arial" panose="020B0604020202020204" pitchFamily="34" charset="0"/>
-              <a:cs typeface="Arial" panose="020B0604020202020204" pitchFamily="34" charset="0"/>
-            </a:endParaRPr>
-          </a:p>
-        </p:txBody>
-      </p:sp>
-      <p:pic>
-        <p:nvPicPr>
-          <p:cNvPr id="82258" name="Picture 82257"/>
-          <p:cNvPicPr>
-            <a:picLocks noChangeAspect="1"/>
-          </p:cNvPicPr>
-          <p:nvPr/>
-        </p:nvPicPr>
-        <p:blipFill>
-          <a:blip r:embed="rId3"/>
-          <a:stretch>
-            <a:fillRect/>
-          </a:stretch>
-        </p:blipFill>
-        <p:spPr>
-          <a:xfrm>
-            <a:off x="598488" y="973399"/>
-            <a:ext cx="7937596" cy="1656600"/>
-          </a:xfrm>
-          <a:prstGeom prst="rect">
-            <a:avLst/>
-          </a:prstGeom>
-        </p:spPr>
-      </p:pic>
-      <p:pic>
-        <p:nvPicPr>
-          <p:cNvPr id="82259" name="Picture 82258"/>
-          <p:cNvPicPr>
-            <a:picLocks noChangeAspect="1"/>
-          </p:cNvPicPr>
-          <p:nvPr/>
-        </p:nvPicPr>
-        <p:blipFill>
-          <a:blip r:embed="rId4"/>
-          <a:stretch>
-            <a:fillRect/>
-          </a:stretch>
-        </p:blipFill>
-        <p:spPr>
-          <a:xfrm>
-            <a:off x="598488" y="2684308"/>
-            <a:ext cx="7937596" cy="1656600"/>
-          </a:xfrm>
-          <a:prstGeom prst="rect">
-            <a:avLst/>
-          </a:prstGeom>
-        </p:spPr>
-      </p:pic>
-      <p:pic>
-        <p:nvPicPr>
-          <p:cNvPr id="82260" name="Picture 82259"/>
-          <p:cNvPicPr>
-            <a:picLocks noChangeAspect="1"/>
-          </p:cNvPicPr>
-          <p:nvPr/>
-        </p:nvPicPr>
-        <p:blipFill>
-          <a:blip r:embed="rId5"/>
-          <a:stretch>
-            <a:fillRect/>
-          </a:stretch>
-        </p:blipFill>
-        <p:spPr>
-          <a:xfrm>
-            <a:off x="598488" y="4406604"/>
-            <a:ext cx="7937596" cy="1656600"/>
-          </a:xfrm>
-          <a:prstGeom prst="rect">
-            <a:avLst/>
-          </a:prstGeom>
-        </p:spPr>
-      </p:pic>
-      <p:sp>
-        <p:nvSpPr>
-          <p:cNvPr id="8984" name="TextBox 8983"/>
-          <p:cNvSpPr txBox="1"/>
-          <p:nvPr/>
-        </p:nvSpPr>
-        <p:spPr>
-          <a:xfrm>
-            <a:off x="127002" y="1397422"/>
-            <a:ext cx="994183" cy="261610"/>
-          </a:xfrm>
-          <a:prstGeom prst="rect">
-            <a:avLst/>
-          </a:prstGeom>
-          <a:noFill/>
-        </p:spPr>
-        <p:txBody>
-          <a:bodyPr wrap="none" rtlCol="0">
-            <a:spAutoFit/>
-          </a:bodyPr>
-          <a:lstStyle/>
-          <a:p>
-            <a:pPr algn="ctr"/>
-            <a:r>
-              <a:rPr lang="en-US" sz="1100" dirty="0" smtClean="0">
-                <a:latin typeface="Arial" panose="020B0604020202020204" pitchFamily="34" charset="0"/>
-                <a:cs typeface="Arial" panose="020B0604020202020204" pitchFamily="34" charset="0"/>
-              </a:rPr>
-              <a:t>Protosyllable</a:t>
-            </a:r>
-            <a:endParaRPr lang="en-US" sz="1100" dirty="0">
-              <a:latin typeface="Arial" panose="020B0604020202020204" pitchFamily="34" charset="0"/>
-              <a:cs typeface="Arial" panose="020B0604020202020204" pitchFamily="34" charset="0"/>
-            </a:endParaRPr>
-          </a:p>
-        </p:txBody>
-      </p:sp>
-      <p:sp>
-        <p:nvSpPr>
-          <p:cNvPr id="8985" name="TextBox 8984"/>
-          <p:cNvSpPr txBox="1"/>
-          <p:nvPr/>
-        </p:nvSpPr>
-        <p:spPr>
-          <a:xfrm>
-            <a:off x="75342" y="3029078"/>
-            <a:ext cx="1101030" cy="430887"/>
-          </a:xfrm>
-          <a:prstGeom prst="rect">
-            <a:avLst/>
-          </a:prstGeom>
-          <a:noFill/>
-        </p:spPr>
-        <p:txBody>
-          <a:bodyPr wrap="square" rtlCol="0">
-            <a:spAutoFit/>
-          </a:bodyPr>
-          <a:lstStyle/>
-          <a:p>
-            <a:pPr algn="ctr"/>
-            <a:r>
-              <a:rPr lang="en-US" sz="1100" dirty="0" smtClean="0">
-                <a:latin typeface="Arial" panose="020B0604020202020204" pitchFamily="34" charset="0"/>
-                <a:cs typeface="Arial" panose="020B0604020202020204" pitchFamily="34" charset="0"/>
-              </a:rPr>
-              <a:t>Partially </a:t>
-            </a:r>
-            <a:r>
-              <a:rPr lang="en-US" sz="1100" dirty="0">
-                <a:latin typeface="Arial" panose="020B0604020202020204" pitchFamily="34" charset="0"/>
-                <a:cs typeface="Arial" panose="020B0604020202020204" pitchFamily="34" charset="0"/>
-              </a:rPr>
-              <a:t>d</a:t>
-            </a:r>
-            <a:r>
-              <a:rPr lang="en-US" sz="1100" dirty="0" smtClean="0">
-                <a:latin typeface="Arial" panose="020B0604020202020204" pitchFamily="34" charset="0"/>
-                <a:cs typeface="Arial" panose="020B0604020202020204" pitchFamily="34" charset="0"/>
-              </a:rPr>
-              <a:t>ifferentiated</a:t>
-            </a:r>
-            <a:endParaRPr lang="en-US" sz="1100" dirty="0">
-              <a:latin typeface="Arial" panose="020B0604020202020204" pitchFamily="34" charset="0"/>
-              <a:cs typeface="Arial" panose="020B0604020202020204" pitchFamily="34" charset="0"/>
-            </a:endParaRPr>
-          </a:p>
-        </p:txBody>
-      </p:sp>
-      <p:sp>
-        <p:nvSpPr>
-          <p:cNvPr id="8986" name="TextBox 8985"/>
-          <p:cNvSpPr txBox="1"/>
-          <p:nvPr/>
-        </p:nvSpPr>
-        <p:spPr>
-          <a:xfrm>
-            <a:off x="-711" y="4797520"/>
-            <a:ext cx="1253136" cy="430887"/>
-          </a:xfrm>
-          <a:prstGeom prst="rect">
-            <a:avLst/>
-          </a:prstGeom>
-          <a:noFill/>
-        </p:spPr>
-        <p:txBody>
-          <a:bodyPr wrap="square" rtlCol="0">
-            <a:spAutoFit/>
-          </a:bodyPr>
-          <a:lstStyle/>
-          <a:p>
-            <a:pPr algn="ctr"/>
-            <a:r>
-              <a:rPr lang="en-US" sz="1100" dirty="0" smtClean="0">
-                <a:latin typeface="Arial" panose="020B0604020202020204" pitchFamily="34" charset="0"/>
-                <a:cs typeface="Arial" panose="020B0604020202020204" pitchFamily="34" charset="0"/>
-              </a:rPr>
-              <a:t>Fully differentiated</a:t>
-            </a:r>
-            <a:endParaRPr lang="en-US" sz="1100" dirty="0">
-              <a:latin typeface="Arial" panose="020B0604020202020204" pitchFamily="34" charset="0"/>
-              <a:cs typeface="Arial" panose="020B0604020202020204" pitchFamily="34" charset="0"/>
-            </a:endParaRPr>
-          </a:p>
-        </p:txBody>
-      </p:sp>
-    </p:spTree>
-    <p:extLst>
-      <p:ext uri="{BB962C8B-B14F-4D97-AF65-F5344CB8AC3E}">
-        <p14:creationId xmlns:p14="http://schemas.microsoft.com/office/powerpoint/2010/main" val="913293255"/>
-      </p:ext>
-    </p:extLst>
-  </p:cSld>
-  <p:clrMapOvr>
-    <a:masterClrMapping/>
-  </p:clrMapOvr>
-  <p:timing>
-    <p:tnLst>
-      <p:par>
-        <p:cTn id="1" dur="indefinite" restart="never" nodeType="tmRoot"/>
-      </p:par>
-    </p:tnLst>
-  </p:timing>
-</p:sld>
-</file>
-
-<file path=ppt/slides/slide4.xml><?xml version="1.0" encoding="utf-8"?>
-<p:sld xmlns:a="http://schemas.openxmlformats.org/drawingml/2006/main" xmlns:r="http://schemas.openxmlformats.org/officeDocument/2006/relationships" xmlns:p="http://schemas.openxmlformats.org/presentationml/2006/main">
-  <p:cSld>
-    <p:spTree>
-      <p:nvGrpSpPr>
-        <p:cNvPr id="1" name=""/>
-        <p:cNvGrpSpPr/>
-        <p:nvPr/>
-      </p:nvGrpSpPr>
-      <p:grpSpPr>
-        <a:xfrm>
-          <a:off x="0" y="0"/>
-          <a:ext cx="0" cy="0"/>
-          <a:chOff x="0" y="0"/>
-          <a:chExt cx="0" cy="0"/>
-        </a:xfrm>
-      </p:grpSpPr>
-      <p:sp>
-        <p:nvSpPr>
-          <p:cNvPr id="2" name="Title 1"/>
-          <p:cNvSpPr>
-            <a:spLocks noGrp="1"/>
-          </p:cNvSpPr>
-          <p:nvPr>
-            <p:ph type="title"/>
-          </p:nvPr>
-        </p:nvSpPr>
-        <p:spPr>
-          <a:xfrm>
-            <a:off x="205488" y="15555"/>
-            <a:ext cx="5915025" cy="741463"/>
-          </a:xfrm>
-        </p:spPr>
-        <p:txBody>
-          <a:bodyPr>
-            <a:normAutofit/>
-          </a:bodyPr>
-          <a:lstStyle/>
-          <a:p>
-            <a:r>
-              <a:rPr lang="en-US" sz="1400" dirty="0" smtClean="0">
-                <a:latin typeface="Arial" panose="020B0604020202020204" pitchFamily="34" charset="0"/>
-                <a:cs typeface="Arial" panose="020B0604020202020204" pitchFamily="34" charset="0"/>
-              </a:rPr>
-              <a:t>Generalized to larger numbers of neurons: chain length  is determined by training interval</a:t>
-            </a:r>
-            <a:endParaRPr lang="en-US" sz="1400" dirty="0">
-              <a:latin typeface="Arial" panose="020B0604020202020204" pitchFamily="34" charset="0"/>
-              <a:cs typeface="Arial" panose="020B0604020202020204" pitchFamily="34" charset="0"/>
-            </a:endParaRPr>
-          </a:p>
-        </p:txBody>
-      </p:sp>
-      <p:sp>
-        <p:nvSpPr>
-          <p:cNvPr id="6" name="TextBox 5"/>
-          <p:cNvSpPr txBox="1"/>
-          <p:nvPr/>
-        </p:nvSpPr>
-        <p:spPr>
-          <a:xfrm>
-            <a:off x="244549" y="706218"/>
-            <a:ext cx="1658531" cy="276999"/>
-          </a:xfrm>
-          <a:prstGeom prst="rect">
-            <a:avLst/>
-          </a:prstGeom>
-          <a:noFill/>
-          <a:ln>
-            <a:solidFill>
-              <a:schemeClr val="tx1"/>
-            </a:solidFill>
-          </a:ln>
-        </p:spPr>
-        <p:txBody>
-          <a:bodyPr wrap="none" rtlCol="0">
-            <a:spAutoFit/>
-          </a:bodyPr>
-          <a:lstStyle/>
-          <a:p>
-            <a:r>
-              <a:rPr lang="en-US" sz="1200" dirty="0" smtClean="0">
-                <a:latin typeface="Arial" panose="020B0604020202020204" pitchFamily="34" charset="0"/>
-                <a:cs typeface="Arial" panose="020B0604020202020204" pitchFamily="34" charset="0"/>
-              </a:rPr>
-              <a:t>Training interval =  20</a:t>
-            </a:r>
-            <a:endParaRPr lang="en-US" sz="1200" dirty="0">
-              <a:latin typeface="Arial" panose="020B0604020202020204" pitchFamily="34" charset="0"/>
-              <a:cs typeface="Arial" panose="020B0604020202020204" pitchFamily="34" charset="0"/>
-            </a:endParaRPr>
-          </a:p>
-        </p:txBody>
-      </p:sp>
-      <p:pic>
-        <p:nvPicPr>
-          <p:cNvPr id="124402" name="Picture 124401"/>
-          <p:cNvPicPr>
-            <a:picLocks noChangeAspect="1"/>
-          </p:cNvPicPr>
-          <p:nvPr/>
-        </p:nvPicPr>
-        <p:blipFill>
-          <a:blip r:embed="rId3"/>
-          <a:stretch>
-            <a:fillRect/>
-          </a:stretch>
-        </p:blipFill>
-        <p:spPr>
-          <a:xfrm>
-            <a:off x="624093" y="985280"/>
-            <a:ext cx="7937596" cy="1656600"/>
-          </a:xfrm>
-          <a:prstGeom prst="rect">
-            <a:avLst/>
-          </a:prstGeom>
-        </p:spPr>
-      </p:pic>
-      <p:pic>
-        <p:nvPicPr>
-          <p:cNvPr id="124405" name="Picture 124404"/>
-          <p:cNvPicPr>
-            <a:picLocks noChangeAspect="1"/>
-          </p:cNvPicPr>
-          <p:nvPr/>
-        </p:nvPicPr>
-        <p:blipFill>
-          <a:blip r:embed="rId4"/>
-          <a:stretch>
-            <a:fillRect/>
-          </a:stretch>
-        </p:blipFill>
-        <p:spPr>
-          <a:xfrm>
-            <a:off x="624093" y="2668354"/>
-            <a:ext cx="7937596" cy="1656600"/>
-          </a:xfrm>
-          <a:prstGeom prst="rect">
-            <a:avLst/>
-          </a:prstGeom>
-        </p:spPr>
-      </p:pic>
-      <p:pic>
-        <p:nvPicPr>
-          <p:cNvPr id="124406" name="Picture 124405"/>
-          <p:cNvPicPr>
-            <a:picLocks noChangeAspect="1"/>
-          </p:cNvPicPr>
-          <p:nvPr/>
-        </p:nvPicPr>
-        <p:blipFill>
-          <a:blip r:embed="rId5"/>
-          <a:stretch>
-            <a:fillRect/>
-          </a:stretch>
-        </p:blipFill>
-        <p:spPr>
-          <a:xfrm>
-            <a:off x="624093" y="4391676"/>
-            <a:ext cx="7937596" cy="1656600"/>
-          </a:xfrm>
-          <a:prstGeom prst="rect">
-            <a:avLst/>
-          </a:prstGeom>
-        </p:spPr>
-      </p:pic>
-      <p:sp>
-        <p:nvSpPr>
-          <p:cNvPr id="7865" name="TextBox 7864"/>
-          <p:cNvSpPr txBox="1"/>
-          <p:nvPr/>
-        </p:nvSpPr>
-        <p:spPr>
-          <a:xfrm>
-            <a:off x="127002" y="1397422"/>
-            <a:ext cx="994183" cy="261610"/>
-          </a:xfrm>
-          <a:prstGeom prst="rect">
-            <a:avLst/>
-          </a:prstGeom>
-          <a:noFill/>
-        </p:spPr>
-        <p:txBody>
-          <a:bodyPr wrap="none" rtlCol="0">
-            <a:spAutoFit/>
-          </a:bodyPr>
-          <a:lstStyle/>
-          <a:p>
-            <a:pPr algn="ctr"/>
-            <a:r>
-              <a:rPr lang="en-US" sz="1100" dirty="0" smtClean="0">
-                <a:latin typeface="Arial" panose="020B0604020202020204" pitchFamily="34" charset="0"/>
-                <a:cs typeface="Arial" panose="020B0604020202020204" pitchFamily="34" charset="0"/>
-              </a:rPr>
-              <a:t>Protosyllable</a:t>
-            </a:r>
-            <a:endParaRPr lang="en-US" sz="1100" dirty="0">
-              <a:latin typeface="Arial" panose="020B0604020202020204" pitchFamily="34" charset="0"/>
-              <a:cs typeface="Arial" panose="020B0604020202020204" pitchFamily="34" charset="0"/>
-            </a:endParaRPr>
-          </a:p>
-        </p:txBody>
-      </p:sp>
-      <p:sp>
-        <p:nvSpPr>
-          <p:cNvPr id="7866" name="TextBox 7865"/>
-          <p:cNvSpPr txBox="1"/>
-          <p:nvPr/>
-        </p:nvSpPr>
-        <p:spPr>
-          <a:xfrm>
-            <a:off x="75342" y="3029078"/>
-            <a:ext cx="1101030" cy="430887"/>
-          </a:xfrm>
-          <a:prstGeom prst="rect">
-            <a:avLst/>
-          </a:prstGeom>
-          <a:noFill/>
-        </p:spPr>
-        <p:txBody>
-          <a:bodyPr wrap="square" rtlCol="0">
-            <a:spAutoFit/>
-          </a:bodyPr>
-          <a:lstStyle/>
-          <a:p>
-            <a:pPr algn="ctr"/>
-            <a:r>
-              <a:rPr lang="en-US" sz="1100" dirty="0" smtClean="0">
-                <a:latin typeface="Arial" panose="020B0604020202020204" pitchFamily="34" charset="0"/>
-                <a:cs typeface="Arial" panose="020B0604020202020204" pitchFamily="34" charset="0"/>
-              </a:rPr>
-              <a:t>Partially </a:t>
-            </a:r>
-            <a:r>
-              <a:rPr lang="en-US" sz="1100" dirty="0">
-                <a:latin typeface="Arial" panose="020B0604020202020204" pitchFamily="34" charset="0"/>
-                <a:cs typeface="Arial" panose="020B0604020202020204" pitchFamily="34" charset="0"/>
-              </a:rPr>
-              <a:t>d</a:t>
-            </a:r>
-            <a:r>
-              <a:rPr lang="en-US" sz="1100" dirty="0" smtClean="0">
-                <a:latin typeface="Arial" panose="020B0604020202020204" pitchFamily="34" charset="0"/>
-                <a:cs typeface="Arial" panose="020B0604020202020204" pitchFamily="34" charset="0"/>
-              </a:rPr>
-              <a:t>ifferentiated</a:t>
-            </a:r>
-            <a:endParaRPr lang="en-US" sz="1100" dirty="0">
-              <a:latin typeface="Arial" panose="020B0604020202020204" pitchFamily="34" charset="0"/>
-              <a:cs typeface="Arial" panose="020B0604020202020204" pitchFamily="34" charset="0"/>
-            </a:endParaRPr>
-          </a:p>
-        </p:txBody>
-      </p:sp>
-      <p:sp>
-        <p:nvSpPr>
-          <p:cNvPr id="7867" name="TextBox 7866"/>
-          <p:cNvSpPr txBox="1"/>
-          <p:nvPr/>
-        </p:nvSpPr>
-        <p:spPr>
-          <a:xfrm>
-            <a:off x="-711" y="4797520"/>
-            <a:ext cx="1253136" cy="430887"/>
-          </a:xfrm>
-          <a:prstGeom prst="rect">
-            <a:avLst/>
-          </a:prstGeom>
-          <a:noFill/>
-        </p:spPr>
-        <p:txBody>
-          <a:bodyPr wrap="square" rtlCol="0">
-            <a:spAutoFit/>
-          </a:bodyPr>
-          <a:lstStyle/>
-          <a:p>
-            <a:pPr algn="ctr"/>
-            <a:r>
-              <a:rPr lang="en-US" sz="1100" dirty="0" smtClean="0">
-                <a:latin typeface="Arial" panose="020B0604020202020204" pitchFamily="34" charset="0"/>
-                <a:cs typeface="Arial" panose="020B0604020202020204" pitchFamily="34" charset="0"/>
-              </a:rPr>
-              <a:t>Fully differentiated</a:t>
-            </a:r>
-            <a:endParaRPr lang="en-US" sz="1100" dirty="0">
-              <a:latin typeface="Arial" panose="020B0604020202020204" pitchFamily="34" charset="0"/>
-              <a:cs typeface="Arial" panose="020B0604020202020204" pitchFamily="34" charset="0"/>
-            </a:endParaRPr>
-          </a:p>
-        </p:txBody>
-      </p:sp>
-    </p:spTree>
-    <p:extLst>
-      <p:ext uri="{BB962C8B-B14F-4D97-AF65-F5344CB8AC3E}">
-        <p14:creationId xmlns:p14="http://schemas.microsoft.com/office/powerpoint/2010/main" val="2254887525"/>
-      </p:ext>
-    </p:extLst>
-  </p:cSld>
-  <p:clrMapOvr>
-    <a:masterClrMapping/>
-  </p:clrMapOvr>
-  <p:timing>
-    <p:tnLst>
-      <p:par>
-        <p:cTn id="1" dur="indefinite" restart="never" nodeType="tmRoot"/>
-      </p:par>
-    </p:tnLst>
-  </p:timing>
-</p:sld>
-</file>
-
-<file path=ppt/slides/slide5.xml><?xml version="1.0" encoding="utf-8"?>
 <p:sld xmlns:a="http://schemas.openxmlformats.org/drawingml/2006/main" xmlns:r="http://schemas.openxmlformats.org/officeDocument/2006/relationships" xmlns:p="http://schemas.openxmlformats.org/presentationml/2006/main">
   <p:cSld>
     <p:spTree>
@@ -35163,7 +35057,7 @@
         <p:spPr>
           <a:xfrm>
             <a:off x="382363" y="5152798"/>
-            <a:ext cx="6250243" cy="1985159"/>
+            <a:ext cx="6250243" cy="2246769"/>
           </a:xfrm>
           <a:prstGeom prst="rect">
             <a:avLst/>
@@ -35175,6 +35069,42 @@
           </a:bodyPr>
           <a:lstStyle/>
           <a:p>
+            <a:pPr>
+              <a:spcAft>
+                <a:spcPts val="600"/>
+              </a:spcAft>
+              <a:defRPr/>
+            </a:pPr>
+            <a:r>
+              <a:rPr lang="en-US" sz="1200" smtClean="0">
+                <a:latin typeface="Arial" panose="020B0604020202020204" pitchFamily="34" charset="0"/>
+                <a:cs typeface="Arial" panose="020B0604020202020204" pitchFamily="34" charset="0"/>
+              </a:rPr>
+              <a:t>Figure </a:t>
+            </a:r>
+            <a:r>
+              <a:rPr lang="en-US" sz="1200">
+                <a:latin typeface="Arial" panose="020B0604020202020204" pitchFamily="34" charset="0"/>
+                <a:cs typeface="Arial" panose="020B0604020202020204" pitchFamily="34" charset="0"/>
+              </a:rPr>
+              <a:t>2</a:t>
+            </a:r>
+            <a:r>
+              <a:rPr lang="en-US" sz="1200" smtClean="0">
+                <a:latin typeface="Arial" panose="020B0604020202020204" pitchFamily="34" charset="0"/>
+                <a:cs typeface="Arial" panose="020B0604020202020204" pitchFamily="34" charset="0"/>
+              </a:rPr>
+              <a:t>: </a:t>
+            </a:r>
+            <a:r>
+              <a:rPr lang="en-US" sz="1200" smtClean="0">
+                <a:latin typeface="Arial" panose="020B0604020202020204" pitchFamily="34" charset="0"/>
+                <a:cs typeface="Arial" panose="020B0604020202020204" pitchFamily="34" charset="0"/>
+              </a:rPr>
+              <a:t>Quanitification of model results</a:t>
+            </a:r>
+          </a:p>
+          <a:p>
             <a:pPr marL="342900" indent="-342900">
               <a:spcAft>
                 <a:spcPts val="600"/>
@@ -35184,11 +35114,18 @@
               <a:defRPr/>
             </a:pPr>
             <a:r>
+              <a:rPr lang="en-US" sz="1200" smtClean="0">
+                <a:latin typeface="Arial" panose="020B0604020202020204" pitchFamily="34" charset="0"/>
+                <a:cs typeface="Arial" panose="020B0604020202020204" pitchFamily="34" charset="0"/>
+              </a:rPr>
+              <a:t>Distribution </a:t>
+            </a:r>
+            <a:r>
               <a:rPr lang="en-US" sz="1200" dirty="0" smtClean="0">
                 <a:latin typeface="Arial" panose="020B0604020202020204" pitchFamily="34" charset="0"/>
                 <a:cs typeface="Arial" panose="020B0604020202020204" pitchFamily="34" charset="0"/>
               </a:rPr>
-              <a:t>Distribution of firing latency of neurons participating in the protosyllable. (</a:t>
+              <a:t>of firing latency of neurons participating in the protosyllable. (</a:t>
             </a:r>
             <a:r>
               <a:rPr lang="en-US" sz="1200" dirty="0">
@@ -35288,6 +35225,640 @@
 </p:sld>
 </file>
 
+<file path=ppt/slides/slide4.xml><?xml version="1.0" encoding="utf-8"?>
+<p:sld xmlns:a="http://schemas.openxmlformats.org/drawingml/2006/main" xmlns:r="http://schemas.openxmlformats.org/officeDocument/2006/relationships" xmlns:p="http://schemas.openxmlformats.org/presentationml/2006/main">
+  <p:cSld>
+    <p:spTree>
+      <p:nvGrpSpPr>
+        <p:cNvPr id="1" name=""/>
+        <p:cNvGrpSpPr/>
+        <p:nvPr/>
+      </p:nvGrpSpPr>
+      <p:grpSpPr>
+        <a:xfrm>
+          <a:off x="0" y="0"/>
+          <a:ext cx="0" cy="0"/>
+          <a:chOff x="0" y="0"/>
+          <a:chExt cx="0" cy="0"/>
+        </a:xfrm>
+      </p:grpSpPr>
+      <p:sp>
+        <p:nvSpPr>
+          <p:cNvPr id="2" name="Title 1"/>
+          <p:cNvSpPr>
+            <a:spLocks noGrp="1"/>
+          </p:cNvSpPr>
+          <p:nvPr>
+            <p:ph type="title"/>
+          </p:nvPr>
+        </p:nvSpPr>
+        <p:spPr>
+          <a:xfrm>
+            <a:off x="85408" y="11227"/>
+            <a:ext cx="5915025" cy="723703"/>
+          </a:xfrm>
+        </p:spPr>
+        <p:txBody>
+          <a:bodyPr>
+            <a:normAutofit/>
+          </a:bodyPr>
+          <a:lstStyle/>
+          <a:p>
+            <a:r>
+              <a:rPr lang="en-US" sz="1400" dirty="0" smtClean="0">
+                <a:latin typeface="Arial" panose="020B0604020202020204" pitchFamily="34" charset="0"/>
+                <a:cs typeface="Arial" panose="020B0604020202020204" pitchFamily="34" charset="0"/>
+              </a:rPr>
+              <a:t>Generalized to wider chains:</a:t>
+            </a:r>
+            <a:br>
+              <a:rPr lang="en-US" sz="1400" dirty="0" smtClean="0">
+                <a:latin typeface="Arial" panose="020B0604020202020204" pitchFamily="34" charset="0"/>
+                <a:cs typeface="Arial" panose="020B0604020202020204" pitchFamily="34" charset="0"/>
+              </a:rPr>
+            </a:br>
+            <a:r>
+              <a:rPr lang="en-US" sz="1400" dirty="0" smtClean="0">
+                <a:latin typeface="Arial" panose="020B0604020202020204" pitchFamily="34" charset="0"/>
+                <a:cs typeface="Arial" panose="020B0604020202020204" pitchFamily="34" charset="0"/>
+              </a:rPr>
+              <a:t>Number of training neurons determines chain width</a:t>
+            </a:r>
+            <a:endParaRPr lang="en-US" sz="1400" dirty="0">
+              <a:latin typeface="Arial" panose="020B0604020202020204" pitchFamily="34" charset="0"/>
+              <a:cs typeface="Arial" panose="020B0604020202020204" pitchFamily="34" charset="0"/>
+            </a:endParaRPr>
+          </a:p>
+        </p:txBody>
+      </p:sp>
+      <p:sp>
+        <p:nvSpPr>
+          <p:cNvPr id="5" name="Rectangle 4"/>
+          <p:cNvSpPr/>
+          <p:nvPr/>
+        </p:nvSpPr>
+        <p:spPr>
+          <a:xfrm>
+            <a:off x="218413" y="634676"/>
+            <a:ext cx="1648488" cy="307777"/>
+          </a:xfrm>
+          <a:prstGeom prst="rect">
+            <a:avLst/>
+          </a:prstGeom>
+          <a:ln>
+            <a:solidFill>
+              <a:schemeClr val="tx1"/>
+            </a:solidFill>
+          </a:ln>
+        </p:spPr>
+        <p:txBody>
+          <a:bodyPr wrap="square">
+            <a:spAutoFit/>
+          </a:bodyPr>
+          <a:lstStyle/>
+          <a:p>
+            <a:r>
+              <a:rPr lang="en-US" sz="1400" dirty="0" smtClean="0">
+                <a:latin typeface="Arial" panose="020B0604020202020204" pitchFamily="34" charset="0"/>
+                <a:cs typeface="Arial" panose="020B0604020202020204" pitchFamily="34" charset="0"/>
+              </a:rPr>
+              <a:t>16 training inputs</a:t>
+            </a:r>
+            <a:endParaRPr lang="en-US" sz="1400" dirty="0">
+              <a:latin typeface="Arial" panose="020B0604020202020204" pitchFamily="34" charset="0"/>
+              <a:cs typeface="Arial" panose="020B0604020202020204" pitchFamily="34" charset="0"/>
+            </a:endParaRPr>
+          </a:p>
+        </p:txBody>
+      </p:sp>
+      <p:pic>
+        <p:nvPicPr>
+          <p:cNvPr id="82258" name="Picture 82257"/>
+          <p:cNvPicPr>
+            <a:picLocks noChangeAspect="1"/>
+          </p:cNvPicPr>
+          <p:nvPr/>
+        </p:nvPicPr>
+        <p:blipFill>
+          <a:blip r:embed="rId3"/>
+          <a:stretch>
+            <a:fillRect/>
+          </a:stretch>
+        </p:blipFill>
+        <p:spPr>
+          <a:xfrm>
+            <a:off x="598488" y="973399"/>
+            <a:ext cx="7937596" cy="1656600"/>
+          </a:xfrm>
+          <a:prstGeom prst="rect">
+            <a:avLst/>
+          </a:prstGeom>
+        </p:spPr>
+      </p:pic>
+      <p:pic>
+        <p:nvPicPr>
+          <p:cNvPr id="82259" name="Picture 82258"/>
+          <p:cNvPicPr>
+            <a:picLocks noChangeAspect="1"/>
+          </p:cNvPicPr>
+          <p:nvPr/>
+        </p:nvPicPr>
+        <p:blipFill>
+          <a:blip r:embed="rId4"/>
+          <a:stretch>
+            <a:fillRect/>
+          </a:stretch>
+        </p:blipFill>
+        <p:spPr>
+          <a:xfrm>
+            <a:off x="598488" y="2684308"/>
+            <a:ext cx="7937596" cy="1656600"/>
+          </a:xfrm>
+          <a:prstGeom prst="rect">
+            <a:avLst/>
+          </a:prstGeom>
+        </p:spPr>
+      </p:pic>
+      <p:pic>
+        <p:nvPicPr>
+          <p:cNvPr id="82260" name="Picture 82259"/>
+          <p:cNvPicPr>
+            <a:picLocks noChangeAspect="1"/>
+          </p:cNvPicPr>
+          <p:nvPr/>
+        </p:nvPicPr>
+        <p:blipFill>
+          <a:blip r:embed="rId5"/>
+          <a:stretch>
+            <a:fillRect/>
+          </a:stretch>
+        </p:blipFill>
+        <p:spPr>
+          <a:xfrm>
+            <a:off x="598488" y="4406604"/>
+            <a:ext cx="7937596" cy="1656600"/>
+          </a:xfrm>
+          <a:prstGeom prst="rect">
+            <a:avLst/>
+          </a:prstGeom>
+        </p:spPr>
+      </p:pic>
+      <p:sp>
+        <p:nvSpPr>
+          <p:cNvPr id="8984" name="TextBox 8983"/>
+          <p:cNvSpPr txBox="1"/>
+          <p:nvPr/>
+        </p:nvSpPr>
+        <p:spPr>
+          <a:xfrm>
+            <a:off x="127002" y="1397422"/>
+            <a:ext cx="994183" cy="261610"/>
+          </a:xfrm>
+          <a:prstGeom prst="rect">
+            <a:avLst/>
+          </a:prstGeom>
+          <a:noFill/>
+        </p:spPr>
+        <p:txBody>
+          <a:bodyPr wrap="none" rtlCol="0">
+            <a:spAutoFit/>
+          </a:bodyPr>
+          <a:lstStyle/>
+          <a:p>
+            <a:pPr algn="ctr"/>
+            <a:r>
+              <a:rPr lang="en-US" sz="1100" dirty="0" smtClean="0">
+                <a:latin typeface="Arial" panose="020B0604020202020204" pitchFamily="34" charset="0"/>
+                <a:cs typeface="Arial" panose="020B0604020202020204" pitchFamily="34" charset="0"/>
+              </a:rPr>
+              <a:t>Protosyllable</a:t>
+            </a:r>
+            <a:endParaRPr lang="en-US" sz="1100" dirty="0">
+              <a:latin typeface="Arial" panose="020B0604020202020204" pitchFamily="34" charset="0"/>
+              <a:cs typeface="Arial" panose="020B0604020202020204" pitchFamily="34" charset="0"/>
+            </a:endParaRPr>
+          </a:p>
+        </p:txBody>
+      </p:sp>
+      <p:sp>
+        <p:nvSpPr>
+          <p:cNvPr id="8985" name="TextBox 8984"/>
+          <p:cNvSpPr txBox="1"/>
+          <p:nvPr/>
+        </p:nvSpPr>
+        <p:spPr>
+          <a:xfrm>
+            <a:off x="75342" y="3029078"/>
+            <a:ext cx="1101030" cy="430887"/>
+          </a:xfrm>
+          <a:prstGeom prst="rect">
+            <a:avLst/>
+          </a:prstGeom>
+          <a:noFill/>
+        </p:spPr>
+        <p:txBody>
+          <a:bodyPr wrap="square" rtlCol="0">
+            <a:spAutoFit/>
+          </a:bodyPr>
+          <a:lstStyle/>
+          <a:p>
+            <a:pPr algn="ctr"/>
+            <a:r>
+              <a:rPr lang="en-US" sz="1100" dirty="0" smtClean="0">
+                <a:latin typeface="Arial" panose="020B0604020202020204" pitchFamily="34" charset="0"/>
+                <a:cs typeface="Arial" panose="020B0604020202020204" pitchFamily="34" charset="0"/>
+              </a:rPr>
+              <a:t>Partially </a:t>
+            </a:r>
+            <a:r>
+              <a:rPr lang="en-US" sz="1100" dirty="0">
+                <a:latin typeface="Arial" panose="020B0604020202020204" pitchFamily="34" charset="0"/>
+                <a:cs typeface="Arial" panose="020B0604020202020204" pitchFamily="34" charset="0"/>
+              </a:rPr>
+              <a:t>d</a:t>
+            </a:r>
+            <a:r>
+              <a:rPr lang="en-US" sz="1100" dirty="0" smtClean="0">
+                <a:latin typeface="Arial" panose="020B0604020202020204" pitchFamily="34" charset="0"/>
+                <a:cs typeface="Arial" panose="020B0604020202020204" pitchFamily="34" charset="0"/>
+              </a:rPr>
+              <a:t>ifferentiated</a:t>
+            </a:r>
+            <a:endParaRPr lang="en-US" sz="1100" dirty="0">
+              <a:latin typeface="Arial" panose="020B0604020202020204" pitchFamily="34" charset="0"/>
+              <a:cs typeface="Arial" panose="020B0604020202020204" pitchFamily="34" charset="0"/>
+            </a:endParaRPr>
+          </a:p>
+        </p:txBody>
+      </p:sp>
+      <p:sp>
+        <p:nvSpPr>
+          <p:cNvPr id="8986" name="TextBox 8985"/>
+          <p:cNvSpPr txBox="1"/>
+          <p:nvPr/>
+        </p:nvSpPr>
+        <p:spPr>
+          <a:xfrm>
+            <a:off x="-711" y="4797520"/>
+            <a:ext cx="1253136" cy="430887"/>
+          </a:xfrm>
+          <a:prstGeom prst="rect">
+            <a:avLst/>
+          </a:prstGeom>
+          <a:noFill/>
+        </p:spPr>
+        <p:txBody>
+          <a:bodyPr wrap="square" rtlCol="0">
+            <a:spAutoFit/>
+          </a:bodyPr>
+          <a:lstStyle/>
+          <a:p>
+            <a:pPr algn="ctr"/>
+            <a:r>
+              <a:rPr lang="en-US" sz="1100" dirty="0" smtClean="0">
+                <a:latin typeface="Arial" panose="020B0604020202020204" pitchFamily="34" charset="0"/>
+                <a:cs typeface="Arial" panose="020B0604020202020204" pitchFamily="34" charset="0"/>
+              </a:rPr>
+              <a:t>Fully differentiated</a:t>
+            </a:r>
+            <a:endParaRPr lang="en-US" sz="1100" dirty="0">
+              <a:latin typeface="Arial" panose="020B0604020202020204" pitchFamily="34" charset="0"/>
+              <a:cs typeface="Arial" panose="020B0604020202020204" pitchFamily="34" charset="0"/>
+            </a:endParaRPr>
+          </a:p>
+        </p:txBody>
+      </p:sp>
+    </p:spTree>
+    <p:extLst>
+      <p:ext uri="{BB962C8B-B14F-4D97-AF65-F5344CB8AC3E}">
+        <p14:creationId xmlns:p14="http://schemas.microsoft.com/office/powerpoint/2010/main" val="913293255"/>
+      </p:ext>
+    </p:extLst>
+  </p:cSld>
+  <p:clrMapOvr>
+    <a:masterClrMapping/>
+  </p:clrMapOvr>
+  <p:timing>
+    <p:tnLst>
+      <p:par>
+        <p:cTn id="1" dur="indefinite" restart="never" nodeType="tmRoot"/>
+      </p:par>
+    </p:tnLst>
+  </p:timing>
+</p:sld>
+</file>
+
+<file path=ppt/slides/slide5.xml><?xml version="1.0" encoding="utf-8"?>
+<p:sld xmlns:a="http://schemas.openxmlformats.org/drawingml/2006/main" xmlns:r="http://schemas.openxmlformats.org/officeDocument/2006/relationships" xmlns:p="http://schemas.openxmlformats.org/presentationml/2006/main">
+  <p:cSld>
+    <p:spTree>
+      <p:nvGrpSpPr>
+        <p:cNvPr id="1" name=""/>
+        <p:cNvGrpSpPr/>
+        <p:nvPr/>
+      </p:nvGrpSpPr>
+      <p:grpSpPr>
+        <a:xfrm>
+          <a:off x="0" y="0"/>
+          <a:ext cx="0" cy="0"/>
+          <a:chOff x="0" y="0"/>
+          <a:chExt cx="0" cy="0"/>
+        </a:xfrm>
+      </p:grpSpPr>
+      <p:sp>
+        <p:nvSpPr>
+          <p:cNvPr id="2" name="Title 1"/>
+          <p:cNvSpPr>
+            <a:spLocks noGrp="1"/>
+          </p:cNvSpPr>
+          <p:nvPr>
+            <p:ph type="title"/>
+          </p:nvPr>
+        </p:nvSpPr>
+        <p:spPr>
+          <a:xfrm>
+            <a:off x="205488" y="15555"/>
+            <a:ext cx="5915025" cy="741463"/>
+          </a:xfrm>
+        </p:spPr>
+        <p:txBody>
+          <a:bodyPr>
+            <a:normAutofit/>
+          </a:bodyPr>
+          <a:lstStyle/>
+          <a:p>
+            <a:r>
+              <a:rPr lang="en-US" sz="1400" dirty="0" smtClean="0">
+                <a:latin typeface="Arial" panose="020B0604020202020204" pitchFamily="34" charset="0"/>
+                <a:cs typeface="Arial" panose="020B0604020202020204" pitchFamily="34" charset="0"/>
+              </a:rPr>
+              <a:t>Generalized to larger numbers of neurons: chain length  is determined by training interval</a:t>
+            </a:r>
+            <a:endParaRPr lang="en-US" sz="1400" dirty="0">
+              <a:latin typeface="Arial" panose="020B0604020202020204" pitchFamily="34" charset="0"/>
+              <a:cs typeface="Arial" panose="020B0604020202020204" pitchFamily="34" charset="0"/>
+            </a:endParaRPr>
+          </a:p>
+        </p:txBody>
+      </p:sp>
+      <p:sp>
+        <p:nvSpPr>
+          <p:cNvPr id="6" name="TextBox 5"/>
+          <p:cNvSpPr txBox="1"/>
+          <p:nvPr/>
+        </p:nvSpPr>
+        <p:spPr>
+          <a:xfrm>
+            <a:off x="244549" y="706218"/>
+            <a:ext cx="1658531" cy="276999"/>
+          </a:xfrm>
+          <a:prstGeom prst="rect">
+            <a:avLst/>
+          </a:prstGeom>
+          <a:noFill/>
+          <a:ln>
+            <a:solidFill>
+              <a:schemeClr val="tx1"/>
+            </a:solidFill>
+          </a:ln>
+        </p:spPr>
+        <p:txBody>
+          <a:bodyPr wrap="none" rtlCol="0">
+            <a:spAutoFit/>
+          </a:bodyPr>
+          <a:lstStyle/>
+          <a:p>
+            <a:r>
+              <a:rPr lang="en-US" sz="1200" dirty="0" smtClean="0">
+                <a:latin typeface="Arial" panose="020B0604020202020204" pitchFamily="34" charset="0"/>
+                <a:cs typeface="Arial" panose="020B0604020202020204" pitchFamily="34" charset="0"/>
+              </a:rPr>
+              <a:t>Training interval =  20</a:t>
+            </a:r>
+            <a:endParaRPr lang="en-US" sz="1200" dirty="0">
+              <a:latin typeface="Arial" panose="020B0604020202020204" pitchFamily="34" charset="0"/>
+              <a:cs typeface="Arial" panose="020B0604020202020204" pitchFamily="34" charset="0"/>
+            </a:endParaRPr>
+          </a:p>
+        </p:txBody>
+      </p:sp>
+      <p:pic>
+        <p:nvPicPr>
+          <p:cNvPr id="124402" name="Picture 124401"/>
+          <p:cNvPicPr>
+            <a:picLocks noChangeAspect="1"/>
+          </p:cNvPicPr>
+          <p:nvPr/>
+        </p:nvPicPr>
+        <p:blipFill>
+          <a:blip r:embed="rId3"/>
+          <a:stretch>
+            <a:fillRect/>
+          </a:stretch>
+        </p:blipFill>
+        <p:spPr>
+          <a:xfrm>
+            <a:off x="624093" y="985280"/>
+            <a:ext cx="7937596" cy="1656600"/>
+          </a:xfrm>
+          <a:prstGeom prst="rect">
+            <a:avLst/>
+          </a:prstGeom>
+        </p:spPr>
+      </p:pic>
+      <p:pic>
+        <p:nvPicPr>
+          <p:cNvPr id="124405" name="Picture 124404"/>
+          <p:cNvPicPr>
+            <a:picLocks noChangeAspect="1"/>
+          </p:cNvPicPr>
+          <p:nvPr/>
+        </p:nvPicPr>
+        <p:blipFill>
+          <a:blip r:embed="rId4"/>
+          <a:stretch>
+            <a:fillRect/>
+          </a:stretch>
+        </p:blipFill>
+        <p:spPr>
+          <a:xfrm>
+            <a:off x="624093" y="2668354"/>
+            <a:ext cx="7937596" cy="1656600"/>
+          </a:xfrm>
+          <a:prstGeom prst="rect">
+            <a:avLst/>
+          </a:prstGeom>
+        </p:spPr>
+      </p:pic>
+      <p:pic>
+        <p:nvPicPr>
+          <p:cNvPr id="124406" name="Picture 124405"/>
+          <p:cNvPicPr>
+            <a:picLocks noChangeAspect="1"/>
+          </p:cNvPicPr>
+          <p:nvPr/>
+        </p:nvPicPr>
+        <p:blipFill>
+          <a:blip r:embed="rId5"/>
+          <a:stretch>
+            <a:fillRect/>
+          </a:stretch>
+        </p:blipFill>
+        <p:spPr>
+          <a:xfrm>
+            <a:off x="624093" y="4391676"/>
+            <a:ext cx="7937596" cy="1656600"/>
+          </a:xfrm>
+          <a:prstGeom prst="rect">
+            <a:avLst/>
+          </a:prstGeom>
+        </p:spPr>
+      </p:pic>
+      <p:sp>
+        <p:nvSpPr>
+          <p:cNvPr id="7865" name="TextBox 7864"/>
+          <p:cNvSpPr txBox="1"/>
+          <p:nvPr/>
+        </p:nvSpPr>
+        <p:spPr>
+          <a:xfrm>
+            <a:off x="127002" y="1397422"/>
+            <a:ext cx="994183" cy="261610"/>
+          </a:xfrm>
+          <a:prstGeom prst="rect">
+            <a:avLst/>
+          </a:prstGeom>
+          <a:noFill/>
+        </p:spPr>
+        <p:txBody>
+          <a:bodyPr wrap="none" rtlCol="0">
+            <a:spAutoFit/>
+          </a:bodyPr>
+          <a:lstStyle/>
+          <a:p>
+            <a:pPr algn="ctr"/>
+            <a:r>
+              <a:rPr lang="en-US" sz="1100" dirty="0" smtClean="0">
+                <a:latin typeface="Arial" panose="020B0604020202020204" pitchFamily="34" charset="0"/>
+                <a:cs typeface="Arial" panose="020B0604020202020204" pitchFamily="34" charset="0"/>
+              </a:rPr>
+              <a:t>Protosyllable</a:t>
+            </a:r>
+            <a:endParaRPr lang="en-US" sz="1100" dirty="0">
+              <a:latin typeface="Arial" panose="020B0604020202020204" pitchFamily="34" charset="0"/>
+              <a:cs typeface="Arial" panose="020B0604020202020204" pitchFamily="34" charset="0"/>
+            </a:endParaRPr>
+          </a:p>
+        </p:txBody>
+      </p:sp>
+      <p:sp>
+        <p:nvSpPr>
+          <p:cNvPr id="7866" name="TextBox 7865"/>
+          <p:cNvSpPr txBox="1"/>
+          <p:nvPr/>
+        </p:nvSpPr>
+        <p:spPr>
+          <a:xfrm>
+            <a:off x="75342" y="3029078"/>
+            <a:ext cx="1101030" cy="430887"/>
+          </a:xfrm>
+          <a:prstGeom prst="rect">
+            <a:avLst/>
+          </a:prstGeom>
+          <a:noFill/>
+        </p:spPr>
+        <p:txBody>
+          <a:bodyPr wrap="square" rtlCol="0">
+            <a:spAutoFit/>
+          </a:bodyPr>
+          <a:lstStyle/>
+          <a:p>
+            <a:pPr algn="ctr"/>
+            <a:r>
+              <a:rPr lang="en-US" sz="1100" dirty="0" smtClean="0">
+                <a:latin typeface="Arial" panose="020B0604020202020204" pitchFamily="34" charset="0"/>
+                <a:cs typeface="Arial" panose="020B0604020202020204" pitchFamily="34" charset="0"/>
+              </a:rPr>
+              <a:t>Partially </a:t>
+            </a:r>
+            <a:r>
+              <a:rPr lang="en-US" sz="1100" dirty="0">
+                <a:latin typeface="Arial" panose="020B0604020202020204" pitchFamily="34" charset="0"/>
+                <a:cs typeface="Arial" panose="020B0604020202020204" pitchFamily="34" charset="0"/>
+              </a:rPr>
+              <a:t>d</a:t>
+            </a:r>
+            <a:r>
+              <a:rPr lang="en-US" sz="1100" dirty="0" smtClean="0">
+                <a:latin typeface="Arial" panose="020B0604020202020204" pitchFamily="34" charset="0"/>
+                <a:cs typeface="Arial" panose="020B0604020202020204" pitchFamily="34" charset="0"/>
+              </a:rPr>
+              <a:t>ifferentiated</a:t>
+            </a:r>
+            <a:endParaRPr lang="en-US" sz="1100" dirty="0">
+              <a:latin typeface="Arial" panose="020B0604020202020204" pitchFamily="34" charset="0"/>
+              <a:cs typeface="Arial" panose="020B0604020202020204" pitchFamily="34" charset="0"/>
+            </a:endParaRPr>
+          </a:p>
+        </p:txBody>
+      </p:sp>
+      <p:sp>
+        <p:nvSpPr>
+          <p:cNvPr id="7867" name="TextBox 7866"/>
+          <p:cNvSpPr txBox="1"/>
+          <p:nvPr/>
+        </p:nvSpPr>
+        <p:spPr>
+          <a:xfrm>
+            <a:off x="-711" y="4797520"/>
+            <a:ext cx="1253136" cy="430887"/>
+          </a:xfrm>
+          <a:prstGeom prst="rect">
+            <a:avLst/>
+          </a:prstGeom>
+          <a:noFill/>
+        </p:spPr>
+        <p:txBody>
+          <a:bodyPr wrap="square" rtlCol="0">
+            <a:spAutoFit/>
+          </a:bodyPr>
+          <a:lstStyle/>
+          <a:p>
+            <a:pPr algn="ctr"/>
+            <a:r>
+              <a:rPr lang="en-US" sz="1100" dirty="0" smtClean="0">
+                <a:latin typeface="Arial" panose="020B0604020202020204" pitchFamily="34" charset="0"/>
+                <a:cs typeface="Arial" panose="020B0604020202020204" pitchFamily="34" charset="0"/>
+              </a:rPr>
+              <a:t>Fully differentiated</a:t>
+            </a:r>
+            <a:endParaRPr lang="en-US" sz="1100" dirty="0">
+              <a:latin typeface="Arial" panose="020B0604020202020204" pitchFamily="34" charset="0"/>
+              <a:cs typeface="Arial" panose="020B0604020202020204" pitchFamily="34" charset="0"/>
+            </a:endParaRPr>
+          </a:p>
+        </p:txBody>
+      </p:sp>
+    </p:spTree>
+    <p:extLst>
+      <p:ext uri="{BB962C8B-B14F-4D97-AF65-F5344CB8AC3E}">
+        <p14:creationId xmlns:p14="http://schemas.microsoft.com/office/powerpoint/2010/main" val="2254887525"/>
+      </p:ext>
+    </p:extLst>
+  </p:cSld>
+  <p:clrMapOvr>
+    <a:masterClrMapping/>
+  </p:clrMapOvr>
+  <p:timing>
+    <p:tnLst>
+      <p:par>
+        <p:cTn id="1" dur="indefinite" restart="never" nodeType="tmRoot"/>
+      </p:par>
+    </p:tnLst>
+  </p:timing>
+</p:sld>
+</file>
+
 <file path=ppt/slides/slide6.xml><?xml version="1.0" encoding="utf-8"?>
 <p:sld xmlns:a="http://schemas.openxmlformats.org/drawingml/2006/main" xmlns:r="http://schemas.openxmlformats.org/officeDocument/2006/relationships" xmlns:p="http://schemas.openxmlformats.org/presentationml/2006/main">
   <p:cSld>
@@ -35321,7 +35892,7 @@
         </p:blipFill>
         <p:spPr>
           <a:xfrm>
-            <a:off x="773814" y="483525"/>
+            <a:off x="773814" y="595819"/>
             <a:ext cx="7937596" cy="1656600"/>
           </a:xfrm>
           <a:prstGeom prst="rect">
@@ -35337,7 +35908,7 @@
         </p:nvSpPr>
         <p:spPr>
           <a:xfrm>
-            <a:off x="212008" y="979947"/>
+            <a:off x="212008" y="1092241"/>
             <a:ext cx="978153" cy="430887"/>
           </a:xfrm>
           <a:prstGeom prst="rect">
@@ -35387,7 +35958,7 @@
         </p:nvSpPr>
         <p:spPr>
           <a:xfrm>
-            <a:off x="152332" y="2595357"/>
+            <a:off x="152332" y="2707651"/>
             <a:ext cx="1101030" cy="261610"/>
           </a:xfrm>
           <a:prstGeom prst="rect">
@@ -35424,7 +35995,7 @@
         </p:nvSpPr>
         <p:spPr>
           <a:xfrm>
-            <a:off x="76279" y="4380045"/>
+            <a:off x="76279" y="4492339"/>
             <a:ext cx="1253136" cy="430887"/>
           </a:xfrm>
           <a:prstGeom prst="rect">
@@ -35474,7 +36045,7 @@
         </p:nvSpPr>
         <p:spPr>
           <a:xfrm>
-            <a:off x="1538429" y="135766"/>
+            <a:off x="1538429" y="344312"/>
             <a:ext cx="1244251" cy="261610"/>
           </a:xfrm>
           <a:prstGeom prst="rect">
@@ -35515,7 +36086,7 @@
         </p:nvSpPr>
         <p:spPr>
           <a:xfrm>
-            <a:off x="3503631" y="135766"/>
+            <a:off x="3503631" y="344312"/>
             <a:ext cx="954107" cy="261610"/>
           </a:xfrm>
           <a:prstGeom prst="rect">
@@ -35556,7 +36127,7 @@
         </p:nvSpPr>
         <p:spPr>
           <a:xfrm>
-            <a:off x="5390851" y="135766"/>
+            <a:off x="5390851" y="344312"/>
             <a:ext cx="954107" cy="261610"/>
           </a:xfrm>
           <a:prstGeom prst="rect">
@@ -35597,7 +36168,7 @@
         </p:nvSpPr>
         <p:spPr>
           <a:xfrm>
-            <a:off x="148347" y="258700"/>
+            <a:off x="148347" y="370994"/>
             <a:ext cx="312906" cy="369332"/>
           </a:xfrm>
           <a:prstGeom prst="rect">
@@ -35633,7 +36204,7 @@
         </p:nvSpPr>
         <p:spPr>
           <a:xfrm>
-            <a:off x="148347" y="1981738"/>
+            <a:off x="148347" y="2094032"/>
             <a:ext cx="325730" cy="369332"/>
           </a:xfrm>
           <a:prstGeom prst="rect">
@@ -35669,7 +36240,7 @@
         </p:nvSpPr>
         <p:spPr>
           <a:xfrm>
-            <a:off x="150947" y="3704870"/>
+            <a:off x="150947" y="3817164"/>
             <a:ext cx="312906" cy="369332"/>
           </a:xfrm>
           <a:prstGeom prst="rect">
@@ -35752,14 +36323,7 @@
                 <a:latin typeface="Arial" panose="020B0604020202020204" pitchFamily="34" charset="0"/>
                 <a:cs typeface="Arial" panose="020B0604020202020204" pitchFamily="34" charset="0"/>
               </a:rPr>
-              <a:t>*k. </a:t>
-            </a:r>
-            <a:r>
-              <a:rPr lang="en-US" sz="1200" dirty="0" smtClean="0">
-                <a:latin typeface="Arial" panose="020B0604020202020204" pitchFamily="34" charset="0"/>
-                <a:cs typeface="Arial" panose="020B0604020202020204" pitchFamily="34" charset="0"/>
-              </a:rPr>
-              <a:t>Wide chains form by sequentially creating many weak synapses, then pruning back to the correct number of strong synapses</a:t>
+              <a:t>*k. Wide chains form by sequentially creating many weak synapses, then pruning back to the correct number of strong synapses</a:t>
             </a:r>
           </a:p>
           <a:p>
@@ -35846,7 +36410,7 @@
         </p:blipFill>
         <p:spPr>
           <a:xfrm>
-            <a:off x="701084" y="2160351"/>
+            <a:off x="701084" y="2272645"/>
             <a:ext cx="7937596" cy="1656600"/>
           </a:xfrm>
           <a:prstGeom prst="rect">
@@ -35870,7 +36434,7 @@
         </p:blipFill>
         <p:spPr>
           <a:xfrm>
-            <a:off x="701084" y="3901046"/>
+            <a:off x="701084" y="4013340"/>
             <a:ext cx="7937596" cy="1656600"/>
           </a:xfrm>
           <a:prstGeom prst="rect">
@@ -35894,7 +36458,7 @@
         </p:blipFill>
         <p:spPr>
           <a:xfrm>
-            <a:off x="701084" y="5614430"/>
+            <a:off x="701084" y="5726724"/>
             <a:ext cx="7937596" cy="1656600"/>
           </a:xfrm>
           <a:prstGeom prst="rect">
@@ -35910,7 +36474,7 @@
         </p:nvSpPr>
         <p:spPr>
           <a:xfrm>
-            <a:off x="80746" y="5980659"/>
+            <a:off x="80746" y="6092953"/>
             <a:ext cx="1253136" cy="430887"/>
           </a:xfrm>
           <a:prstGeom prst="rect">
@@ -35947,7 +36511,7 @@
         </p:nvSpPr>
         <p:spPr>
           <a:xfrm>
-            <a:off x="155414" y="5388609"/>
+            <a:off x="155414" y="5500903"/>
             <a:ext cx="312906" cy="369332"/>
           </a:xfrm>
           <a:prstGeom prst="rect">
@@ -35975,6 +36539,43 @@
           </a:p>
         </p:txBody>
       </p:sp>
+      <p:sp>
+        <p:nvSpPr>
+          <p:cNvPr id="2" name="Rectangle 1"/>
+          <p:cNvSpPr/>
+          <p:nvPr/>
+        </p:nvSpPr>
+        <p:spPr>
+          <a:xfrm>
+            <a:off x="76279" y="39712"/>
+            <a:ext cx="2570668" cy="307777"/>
+          </a:xfrm>
+          <a:prstGeom prst="rect">
+            <a:avLst/>
+          </a:prstGeom>
+          <a:ln>
+            <a:solidFill>
+              <a:schemeClr val="tx1"/>
+            </a:solidFill>
+          </a:ln>
+        </p:spPr>
+        <p:txBody>
+          <a:bodyPr wrap="square">
+            <a:spAutoFit/>
+          </a:bodyPr>
+          <a:lstStyle/>
+          <a:p>
+            <a:r>
+              <a:rPr lang="en-US" sz="1400" smtClean="0">
+                <a:latin typeface="Arial" panose="020B0604020202020204" pitchFamily="34" charset="0"/>
+                <a:cs typeface="Arial" panose="020B0604020202020204" pitchFamily="34" charset="0"/>
+              </a:rPr>
+              <a:t>Generalized for noisy firing</a:t>
+            </a:r>
+            <a:endParaRPr lang="en-US" sz="1400"/>
+          </a:p>
+        </p:txBody>
+      </p:sp>
     </p:spTree>
     <p:extLst>
       <p:ext uri="{BB962C8B-B14F-4D97-AF65-F5344CB8AC3E}">
@@ -35985,6 +36586,245 @@
   <p:clrMapOvr>
     <a:masterClrMapping/>
   </p:clrMapOvr>
+  <p:timing>
+    <p:tnLst>
+      <p:par>
+        <p:cTn id="1" dur="indefinite" restart="never" nodeType="tmRoot"/>
+      </p:par>
+    </p:tnLst>
+  </p:timing>
+</p:sld>
+</file>
+
+<file path=ppt/slides/slide7.xml><?xml version="1.0" encoding="utf-8"?>
+<p:sld xmlns:a="http://schemas.openxmlformats.org/drawingml/2006/main" xmlns:r="http://schemas.openxmlformats.org/officeDocument/2006/relationships" xmlns:p="http://schemas.openxmlformats.org/presentationml/2006/main">
+  <p:cSld>
+    <p:spTree>
+      <p:nvGrpSpPr>
+        <p:cNvPr id="1" name=""/>
+        <p:cNvGrpSpPr/>
+        <p:nvPr/>
+      </p:nvGrpSpPr>
+      <p:grpSpPr>
+        <a:xfrm>
+          <a:off x="0" y="0"/>
+          <a:ext cx="0" cy="0"/>
+          <a:chOff x="0" y="0"/>
+          <a:chExt cx="0" cy="0"/>
+        </a:xfrm>
+      </p:grpSpPr>
+      <p:sp>
+        <p:nvSpPr>
+          <p:cNvPr id="2" name="Title 1"/>
+          <p:cNvSpPr>
+            <a:spLocks noGrp="1"/>
+          </p:cNvSpPr>
+          <p:nvPr>
+            <p:ph type="title"/>
+          </p:nvPr>
+        </p:nvSpPr>
+        <p:spPr>
+          <a:xfrm>
+            <a:off x="471488" y="486837"/>
+            <a:ext cx="5915025" cy="656164"/>
+          </a:xfrm>
+        </p:spPr>
+        <p:txBody>
+          <a:bodyPr/>
+          <a:lstStyle/>
+          <a:p>
+            <a:r>
+              <a:rPr lang="en-US" smtClean="0"/>
+              <a:t>Adaptation not strictly necessary</a:t>
+            </a:r>
+            <a:endParaRPr lang="en-US"/>
+          </a:p>
+        </p:txBody>
+      </p:sp>
+      <p:pic>
+        <p:nvPicPr>
+          <p:cNvPr id="7" name="Picture 6"/>
+          <p:cNvPicPr>
+            <a:picLocks noChangeAspect="1"/>
+          </p:cNvPicPr>
+          <p:nvPr/>
+        </p:nvPicPr>
+        <p:blipFill>
+          <a:blip r:embed="rId3"/>
+          <a:stretch>
+            <a:fillRect/>
+          </a:stretch>
+        </p:blipFill>
+        <p:spPr>
+          <a:xfrm>
+            <a:off x="253327" y="1525686"/>
+            <a:ext cx="6351346" cy="1326600"/>
+          </a:xfrm>
+          <a:prstGeom prst="rect">
+            <a:avLst/>
+          </a:prstGeom>
+        </p:spPr>
+      </p:pic>
+      <p:sp>
+        <p:nvSpPr>
+          <p:cNvPr id="9" name="TextBox 8"/>
+          <p:cNvSpPr txBox="1"/>
+          <p:nvPr/>
+        </p:nvSpPr>
+        <p:spPr>
+          <a:xfrm>
+            <a:off x="471488" y="1178202"/>
+            <a:ext cx="1063112" cy="261610"/>
+          </a:xfrm>
+          <a:prstGeom prst="rect">
+            <a:avLst/>
+          </a:prstGeom>
+          <a:noFill/>
+          <a:ln>
+            <a:solidFill>
+              <a:schemeClr val="tx1"/>
+            </a:solidFill>
+          </a:ln>
+        </p:spPr>
+        <p:txBody>
+          <a:bodyPr wrap="none" rtlCol="0">
+            <a:spAutoFit/>
+          </a:bodyPr>
+          <a:lstStyle/>
+          <a:p>
+            <a:r>
+              <a:rPr lang="en-US" sz="1100" smtClean="0">
+                <a:latin typeface="Arial" panose="020B0604020202020204" pitchFamily="34" charset="0"/>
+                <a:cs typeface="Arial" panose="020B0604020202020204" pitchFamily="34" charset="0"/>
+              </a:rPr>
+              <a:t>No adaptation</a:t>
+            </a:r>
+            <a:endParaRPr lang="en-US" sz="1100" dirty="0">
+              <a:latin typeface="Arial" panose="020B0604020202020204" pitchFamily="34" charset="0"/>
+              <a:cs typeface="Arial" panose="020B0604020202020204" pitchFamily="34" charset="0"/>
+            </a:endParaRPr>
+          </a:p>
+        </p:txBody>
+      </p:sp>
+      <p:pic>
+        <p:nvPicPr>
+          <p:cNvPr id="10" name="Picture 9"/>
+          <p:cNvPicPr>
+            <a:picLocks noChangeAspect="1"/>
+          </p:cNvPicPr>
+          <p:nvPr/>
+        </p:nvPicPr>
+        <p:blipFill>
+          <a:blip r:embed="rId4"/>
+          <a:stretch>
+            <a:fillRect/>
+          </a:stretch>
+        </p:blipFill>
+        <p:spPr>
+          <a:xfrm>
+            <a:off x="253327" y="3055549"/>
+            <a:ext cx="6351346" cy="1326600"/>
+          </a:xfrm>
+          <a:prstGeom prst="rect">
+            <a:avLst/>
+          </a:prstGeom>
+        </p:spPr>
+      </p:pic>
+      <p:pic>
+        <p:nvPicPr>
+          <p:cNvPr id="11" name="Picture 10"/>
+          <p:cNvPicPr>
+            <a:picLocks noChangeAspect="1"/>
+          </p:cNvPicPr>
+          <p:nvPr/>
+        </p:nvPicPr>
+        <p:blipFill>
+          <a:blip r:embed="rId5"/>
+          <a:stretch>
+            <a:fillRect/>
+          </a:stretch>
+        </p:blipFill>
+        <p:spPr>
+          <a:xfrm>
+            <a:off x="253327" y="4667471"/>
+            <a:ext cx="6351346" cy="1326600"/>
+          </a:xfrm>
+          <a:prstGeom prst="rect">
+            <a:avLst/>
+          </a:prstGeom>
+        </p:spPr>
+      </p:pic>
+      <p:pic>
+        <p:nvPicPr>
+          <p:cNvPr id="12" name="Picture 11"/>
+          <p:cNvPicPr>
+            <a:picLocks noChangeAspect="1"/>
+          </p:cNvPicPr>
+          <p:nvPr/>
+        </p:nvPicPr>
+        <p:blipFill>
+          <a:blip r:embed="rId6"/>
+          <a:stretch>
+            <a:fillRect/>
+          </a:stretch>
+        </p:blipFill>
+        <p:spPr>
+          <a:xfrm>
+            <a:off x="408289" y="7355285"/>
+            <a:ext cx="6351346" cy="1326600"/>
+          </a:xfrm>
+          <a:prstGeom prst="rect">
+            <a:avLst/>
+          </a:prstGeom>
+        </p:spPr>
+      </p:pic>
+      <p:sp>
+        <p:nvSpPr>
+          <p:cNvPr id="13" name="TextBox 12"/>
+          <p:cNvSpPr txBox="1"/>
+          <p:nvPr/>
+        </p:nvSpPr>
+        <p:spPr>
+          <a:xfrm>
+            <a:off x="471488" y="6805246"/>
+            <a:ext cx="1849681" cy="646331"/>
+          </a:xfrm>
+          <a:prstGeom prst="rect">
+            <a:avLst/>
+          </a:prstGeom>
+          <a:noFill/>
+        </p:spPr>
+        <p:txBody>
+          <a:bodyPr wrap="square" rtlCol="0">
+            <a:spAutoFit/>
+          </a:bodyPr>
+          <a:lstStyle/>
+          <a:p>
+            <a:r>
+              <a:rPr lang="en-US" smtClean="0"/>
+              <a:t>But with gamma = .1:</a:t>
+            </a:r>
+            <a:endParaRPr lang="en-US"/>
+          </a:p>
+        </p:txBody>
+      </p:sp>
+    </p:spTree>
+    <p:extLst>
+      <p:ext uri="{BB962C8B-B14F-4D97-AF65-F5344CB8AC3E}">
+        <p14:creationId xmlns:p14="http://schemas.microsoft.com/office/powerpoint/2010/main" val="1595119335"/>
+      </p:ext>
+    </p:extLst>
+  </p:cSld>
+  <p:clrMapOvr>
+    <a:masterClrMapping/>
+  </p:clrMapOvr>
+  <p:timing>
+    <p:tnLst>
+      <p:par>
+        <p:cTn id="1" dur="indefinite" restart="never" nodeType="tmRoot"/>
+      </p:par>
+    </p:tnLst>
+  </p:timing>
 </p:sld>
 </file>
 

</xml_diff>